<commit_message>
feat: make the curriculum delivery-ready
Harden the full offering so instructors and learners can run a coherent, verified program with governed AI-program content, complete reference apps, aligned teaching artifacts, and enforceable release checks.

Checks passed: build ✓ | lint ✓ | test ✓ | arch ✓ | pr-req ✓
</commit_message>
<xml_diff>
--- a/marketing/decks/phase-00-opening-ai-dev.pptx
+++ b/marketing/decks/phase-00-opening-ai-dev.pptx
@@ -2,125 +2,30 @@
 <file path=ppt/presentation.xml><?xml version="1.0" encoding="utf-8"?>
 <p:presentation xmlns:p="http://schemas.openxmlformats.org/presentationml/2006/main">
   <p:sldMasterIdLst>
-    <p:sldMasterId xmlns:r="http://schemas.openxmlformats.org/officeDocument/2006/relationships" id="2147483648" r:id="Re854f2a07baf4038"/>
+    <p:sldMasterId xmlns:r="http://schemas.openxmlformats.org/officeDocument/2006/relationships" id="2147483648" r:id="Rb6f226f7f4b04a78"/>
   </p:sldMasterIdLst>
   <p:notesMasterIdLst>
-    <p:notesMasterId xmlns:r="http://schemas.openxmlformats.org/officeDocument/2006/relationships" r:id="Rb2807e6fc12e45c7"/>
+    <p:notesMasterId xmlns:r="http://schemas.openxmlformats.org/officeDocument/2006/relationships" r:id="R3685345c3ccf4501"/>
   </p:notesMasterIdLst>
   <p:sldIdLst>
-    <p:sldId xmlns:r="http://schemas.openxmlformats.org/officeDocument/2006/relationships" id="256" r:id="R626fe8fcdb484dc3"/>
-    <p:sldId xmlns:r="http://schemas.openxmlformats.org/officeDocument/2006/relationships" id="257" r:id="R6d76c406194545c2"/>
-    <p:sldId xmlns:r="http://schemas.openxmlformats.org/officeDocument/2006/relationships" id="258" r:id="R21a9117706b74687"/>
-    <p:sldId xmlns:r="http://schemas.openxmlformats.org/officeDocument/2006/relationships" id="259" r:id="R22355ef358704d91"/>
-    <p:sldId xmlns:r="http://schemas.openxmlformats.org/officeDocument/2006/relationships" id="260" r:id="R7b133eff774145c4"/>
-    <p:sldId xmlns:r="http://schemas.openxmlformats.org/officeDocument/2006/relationships" id="261" r:id="Rec50848dcd004211"/>
-    <p:sldId xmlns:r="http://schemas.openxmlformats.org/officeDocument/2006/relationships" id="262" r:id="R76343f76edaf4868"/>
-    <p:sldId xmlns:r="http://schemas.openxmlformats.org/officeDocument/2006/relationships" id="263" r:id="Rc764f534aba14005"/>
-    <p:sldId xmlns:r="http://schemas.openxmlformats.org/officeDocument/2006/relationships" id="264" r:id="R9fd6734277cd4abc"/>
-    <p:sldId xmlns:r="http://schemas.openxmlformats.org/officeDocument/2006/relationships" id="265" r:id="R9818b46ec4f745c6"/>
-    <p:sldId xmlns:r="http://schemas.openxmlformats.org/officeDocument/2006/relationships" id="266" r:id="Rb4a1937cf1e842ae"/>
-    <p:sldId xmlns:r="http://schemas.openxmlformats.org/officeDocument/2006/relationships" id="267" r:id="R50268dd5a0254455"/>
-    <p:sldId xmlns:r="http://schemas.openxmlformats.org/officeDocument/2006/relationships" id="268" r:id="R726dd1a7a8834714"/>
-    <p:sldId xmlns:r="http://schemas.openxmlformats.org/officeDocument/2006/relationships" id="269" r:id="R77967a9fdfc44260"/>
-    <p:sldId xmlns:r="http://schemas.openxmlformats.org/officeDocument/2006/relationships" id="270" r:id="R5fdbec5ad8e0484d"/>
+    <p:sldId xmlns:r="http://schemas.openxmlformats.org/officeDocument/2006/relationships" id="256" r:id="R644e2250f3214a05"/>
+    <p:sldId xmlns:r="http://schemas.openxmlformats.org/officeDocument/2006/relationships" id="257" r:id="R6a164099286e4175"/>
+    <p:sldId xmlns:r="http://schemas.openxmlformats.org/officeDocument/2006/relationships" id="258" r:id="Rf74387f8d99740e0"/>
+    <p:sldId xmlns:r="http://schemas.openxmlformats.org/officeDocument/2006/relationships" id="259" r:id="R620517b850e04cf7"/>
+    <p:sldId xmlns:r="http://schemas.openxmlformats.org/officeDocument/2006/relationships" id="260" r:id="R9e5ae48d81734744"/>
+    <p:sldId xmlns:r="http://schemas.openxmlformats.org/officeDocument/2006/relationships" id="261" r:id="R7558229f4c964787"/>
+    <p:sldId xmlns:r="http://schemas.openxmlformats.org/officeDocument/2006/relationships" id="262" r:id="R2beb00c4452f4a77"/>
+    <p:sldId xmlns:r="http://schemas.openxmlformats.org/officeDocument/2006/relationships" id="263" r:id="R8c8b3a8d01fd40d0"/>
+    <p:sldId xmlns:r="http://schemas.openxmlformats.org/officeDocument/2006/relationships" id="264" r:id="R95db390f1fb14a18"/>
+    <p:sldId xmlns:r="http://schemas.openxmlformats.org/officeDocument/2006/relationships" id="265" r:id="Re782f59bba3e4d2f"/>
+    <p:sldId xmlns:r="http://schemas.openxmlformats.org/officeDocument/2006/relationships" id="266" r:id="R60f6abb7c6134e46"/>
+    <p:sldId xmlns:r="http://schemas.openxmlformats.org/officeDocument/2006/relationships" id="267" r:id="R5e74dc9329384bb9"/>
+    <p:sldId xmlns:r="http://schemas.openxmlformats.org/officeDocument/2006/relationships" id="268" r:id="Rc7d532b0f68a40a2"/>
+    <p:sldId xmlns:r="http://schemas.openxmlformats.org/officeDocument/2006/relationships" id="269" r:id="Re2719020ede2435e"/>
+    <p:sldId xmlns:r="http://schemas.openxmlformats.org/officeDocument/2006/relationships" id="270" r:id="Ra610e98c2c8d4168"/>
   </p:sldIdLst>
   <p:sldSz cx="12192000" cy="6858000"/>
   <p:notesSz cx="6858000" cy="9144000"/>
-  <p:defaultTextStyle>
-    <a:defPPr xmlns:a="http://schemas.openxmlformats.org/drawingml/2006/main">
-      <a:defRPr lang="en-US"/>
-    </a:defPPr>
-    <a:lvl1pPr xmlns:a="http://schemas.openxmlformats.org/drawingml/2006/main" marL="0" indent="0" algn="l" defTabSz="914400">
-      <a:defRPr sz="1800" kern="1200">
-        <a:solidFill>
-          <a:schemeClr val="tx1"/>
-        </a:solidFill>
-        <a:latin typeface="+mn-lt"/>
-        <a:ea typeface="+mn-ea"/>
-        <a:cs typeface="+mn-cs"/>
-      </a:defRPr>
-    </a:lvl1pPr>
-    <a:lvl2pPr xmlns:a="http://schemas.openxmlformats.org/drawingml/2006/main" marL="457200" indent="0" algn="l" defTabSz="914400">
-      <a:defRPr sz="1800" kern="1200">
-        <a:solidFill>
-          <a:schemeClr val="tx1"/>
-        </a:solidFill>
-        <a:latin typeface="+mn-lt"/>
-        <a:ea typeface="+mn-ea"/>
-        <a:cs typeface="+mn-cs"/>
-      </a:defRPr>
-    </a:lvl2pPr>
-    <a:lvl3pPr xmlns:a="http://schemas.openxmlformats.org/drawingml/2006/main" marL="914400" indent="0" algn="l" defTabSz="914400">
-      <a:defRPr sz="1800" kern="1200">
-        <a:solidFill>
-          <a:schemeClr val="tx1"/>
-        </a:solidFill>
-        <a:latin typeface="+mn-lt"/>
-        <a:ea typeface="+mn-ea"/>
-        <a:cs typeface="+mn-cs"/>
-      </a:defRPr>
-    </a:lvl3pPr>
-    <a:lvl4pPr xmlns:a="http://schemas.openxmlformats.org/drawingml/2006/main" marL="1371600" indent="0" algn="l" defTabSz="914400">
-      <a:defRPr sz="1800" kern="1200">
-        <a:solidFill>
-          <a:schemeClr val="tx1"/>
-        </a:solidFill>
-        <a:latin typeface="+mn-lt"/>
-        <a:ea typeface="+mn-ea"/>
-        <a:cs typeface="+mn-cs"/>
-      </a:defRPr>
-    </a:lvl4pPr>
-    <a:lvl5pPr xmlns:a="http://schemas.openxmlformats.org/drawingml/2006/main" marL="1828800" indent="0" algn="l" defTabSz="914400">
-      <a:defRPr sz="1800" kern="1200">
-        <a:solidFill>
-          <a:schemeClr val="tx1"/>
-        </a:solidFill>
-        <a:latin typeface="+mn-lt"/>
-        <a:ea typeface="+mn-ea"/>
-        <a:cs typeface="+mn-cs"/>
-      </a:defRPr>
-    </a:lvl5pPr>
-    <a:lvl6pPr xmlns:a="http://schemas.openxmlformats.org/drawingml/2006/main" marL="2286000" indent="0" algn="l" defTabSz="914400">
-      <a:defRPr sz="1800" kern="1200">
-        <a:solidFill>
-          <a:schemeClr val="tx1"/>
-        </a:solidFill>
-        <a:latin typeface="+mn-lt"/>
-        <a:ea typeface="+mn-ea"/>
-        <a:cs typeface="+mn-cs"/>
-      </a:defRPr>
-    </a:lvl6pPr>
-    <a:lvl7pPr xmlns:a="http://schemas.openxmlformats.org/drawingml/2006/main" marL="2743200" indent="0" algn="l" defTabSz="914400">
-      <a:defRPr sz="1800" kern="1200">
-        <a:solidFill>
-          <a:schemeClr val="tx1"/>
-        </a:solidFill>
-        <a:latin typeface="+mn-lt"/>
-        <a:ea typeface="+mn-ea"/>
-        <a:cs typeface="+mn-cs"/>
-      </a:defRPr>
-    </a:lvl7pPr>
-    <a:lvl8pPr xmlns:a="http://schemas.openxmlformats.org/drawingml/2006/main" marL="3200400" indent="0" algn="l" defTabSz="914400">
-      <a:defRPr sz="1800" kern="1200">
-        <a:solidFill>
-          <a:schemeClr val="tx1"/>
-        </a:solidFill>
-        <a:latin typeface="+mn-lt"/>
-        <a:ea typeface="+mn-ea"/>
-        <a:cs typeface="+mn-cs"/>
-      </a:defRPr>
-    </a:lvl8pPr>
-    <a:lvl9pPr xmlns:a="http://schemas.openxmlformats.org/drawingml/2006/main" marL="3657600" indent="0" algn="l" defTabSz="914400">
-      <a:defRPr sz="1800" kern="1200">
-        <a:solidFill>
-          <a:schemeClr val="tx1"/>
-        </a:solidFill>
-        <a:latin typeface="+mn-lt"/>
-        <a:ea typeface="+mn-ea"/>
-        <a:cs typeface="+mn-cs"/>
-      </a:defRPr>
-    </a:lvl9pPr>
-  </p:defaultTextStyle>
 </p:presentation>
 </file>
 
@@ -1674,7 +1579,7 @@
   </p:cSld>
   <p:clrMap bg1="lt1" tx1="dk1" bg2="lt2" tx2="dk2" accent1="accent1" accent2="accent2" accent3="accent3" accent4="accent4" accent5="accent5" accent6="accent6" hlink="hlink" folHlink="folHlink"/>
   <p:sldLayoutIdLst>
-    <p:sldLayoutId xmlns:r="http://schemas.openxmlformats.org/officeDocument/2006/relationships" id="2147483649" r:id="Rc0973c1b78504d01"/>
+    <p:sldLayoutId xmlns:r="http://schemas.openxmlformats.org/officeDocument/2006/relationships" id="2147483649" r:id="R5785a8d1976241ec"/>
   </p:sldLayoutIdLst>
   <p:txStyles>
     <p:titleStyle>
@@ -2253,6 +2158,7 @@
           <a:lstStyle xmlns:a="http://schemas.openxmlformats.org/drawingml/2006/main"/>
           <a:p xmlns:a="http://schemas.openxmlformats.org/drawingml/2006/main">
             <a:pPr algn="l">
+              <a:buNone/>
               <a:defRPr sz="4350" b="1">
                 <a:solidFill>
                   <a:srgbClr val="000000"/>
@@ -2303,6 +2209,7 @@
           <a:lstStyle xmlns:a="http://schemas.openxmlformats.org/drawingml/2006/main"/>
           <a:p xmlns:a="http://schemas.openxmlformats.org/drawingml/2006/main">
             <a:pPr algn="l">
+              <a:buNone/>
               <a:defRPr sz="4350" b="1">
                 <a:solidFill>
                   <a:srgbClr val="000000"/>
@@ -2353,6 +2260,7 @@
           <a:lstStyle xmlns:a="http://schemas.openxmlformats.org/drawingml/2006/main"/>
           <a:p xmlns:a="http://schemas.openxmlformats.org/drawingml/2006/main">
             <a:pPr algn="l">
+              <a:buNone/>
               <a:defRPr sz="1875" b="0">
                 <a:solidFill>
                   <a:srgbClr val="60646C"/>
@@ -2434,6 +2342,7 @@
           <a:lstStyle xmlns:a="http://schemas.openxmlformats.org/drawingml/2006/main"/>
           <a:p xmlns:a="http://schemas.openxmlformats.org/drawingml/2006/main">
             <a:pPr algn="l">
+              <a:buNone/>
               <a:defRPr sz="2175" b="0">
                 <a:solidFill>
                   <a:srgbClr val="000000"/>
@@ -2484,6 +2393,7 @@
           <a:lstStyle xmlns:a="http://schemas.openxmlformats.org/drawingml/2006/main"/>
           <a:p xmlns:a="http://schemas.openxmlformats.org/drawingml/2006/main">
             <a:pPr algn="r">
+              <a:buNone/>
               <a:defRPr sz="975" b="0">
                 <a:solidFill>
                   <a:srgbClr val="60646C"/>
@@ -2556,6 +2466,7 @@
           <a:lstStyle xmlns:a="http://schemas.openxmlformats.org/drawingml/2006/main"/>
           <a:p xmlns:a="http://schemas.openxmlformats.org/drawingml/2006/main">
             <a:pPr algn="l">
+              <a:buNone/>
               <a:defRPr sz="1125" b="1">
                 <a:solidFill>
                   <a:srgbClr val="60646C"/>
@@ -2606,6 +2517,7 @@
           <a:lstStyle xmlns:a="http://schemas.openxmlformats.org/drawingml/2006/main"/>
           <a:p xmlns:a="http://schemas.openxmlformats.org/drawingml/2006/main">
             <a:pPr algn="l">
+              <a:buNone/>
               <a:defRPr sz="3750" b="1">
                 <a:solidFill>
                   <a:srgbClr val="000000"/>
@@ -2689,6 +2601,7 @@
           <a:lstStyle xmlns:a="http://schemas.openxmlformats.org/drawingml/2006/main"/>
           <a:p xmlns:a="http://schemas.openxmlformats.org/drawingml/2006/main">
             <a:pPr algn="l">
+              <a:buNone/>
               <a:defRPr sz="2175" b="1">
                 <a:solidFill>
                   <a:srgbClr val="000000"/>
@@ -2739,6 +2652,7 @@
           <a:lstStyle xmlns:a="http://schemas.openxmlformats.org/drawingml/2006/main"/>
           <a:p xmlns:a="http://schemas.openxmlformats.org/drawingml/2006/main">
             <a:pPr algn="l">
+              <a:buNone/>
               <a:defRPr sz="1575" b="1">
                 <a:solidFill>
                   <a:srgbClr val="3D8DFF"/>
@@ -2789,6 +2703,7 @@
           <a:lstStyle xmlns:a="http://schemas.openxmlformats.org/drawingml/2006/main"/>
           <a:p xmlns:a="http://schemas.openxmlformats.org/drawingml/2006/main">
             <a:pPr algn="l">
+              <a:buNone/>
               <a:defRPr sz="1575" b="0">
                 <a:solidFill>
                   <a:srgbClr val="000000"/>
@@ -2839,6 +2754,7 @@
           <a:lstStyle xmlns:a="http://schemas.openxmlformats.org/drawingml/2006/main"/>
           <a:p xmlns:a="http://schemas.openxmlformats.org/drawingml/2006/main">
             <a:pPr algn="l">
+              <a:buNone/>
               <a:defRPr sz="1575" b="1">
                 <a:solidFill>
                   <a:srgbClr val="3D8DFF"/>
@@ -2889,6 +2805,7 @@
           <a:lstStyle xmlns:a="http://schemas.openxmlformats.org/drawingml/2006/main"/>
           <a:p xmlns:a="http://schemas.openxmlformats.org/drawingml/2006/main">
             <a:pPr algn="l">
+              <a:buNone/>
               <a:defRPr sz="1575" b="0">
                 <a:solidFill>
                   <a:srgbClr val="000000"/>
@@ -2939,6 +2856,7 @@
           <a:lstStyle xmlns:a="http://schemas.openxmlformats.org/drawingml/2006/main"/>
           <a:p xmlns:a="http://schemas.openxmlformats.org/drawingml/2006/main">
             <a:pPr algn="l">
+              <a:buNone/>
               <a:defRPr sz="1575" b="1">
                 <a:solidFill>
                   <a:srgbClr val="3D8DFF"/>
@@ -2989,6 +2907,7 @@
           <a:lstStyle xmlns:a="http://schemas.openxmlformats.org/drawingml/2006/main"/>
           <a:p xmlns:a="http://schemas.openxmlformats.org/drawingml/2006/main">
             <a:pPr algn="l">
+              <a:buNone/>
               <a:defRPr sz="1575" b="0">
                 <a:solidFill>
                   <a:srgbClr val="000000"/>
@@ -3039,6 +2958,7 @@
           <a:lstStyle xmlns:a="http://schemas.openxmlformats.org/drawingml/2006/main"/>
           <a:p xmlns:a="http://schemas.openxmlformats.org/drawingml/2006/main">
             <a:pPr algn="l">
+              <a:buNone/>
               <a:defRPr sz="1575" b="1">
                 <a:solidFill>
                   <a:srgbClr val="3D8DFF"/>
@@ -3089,6 +3009,7 @@
           <a:lstStyle xmlns:a="http://schemas.openxmlformats.org/drawingml/2006/main"/>
           <a:p xmlns:a="http://schemas.openxmlformats.org/drawingml/2006/main">
             <a:pPr algn="l">
+              <a:buNone/>
               <a:defRPr sz="1575" b="0">
                 <a:solidFill>
                   <a:srgbClr val="000000"/>
@@ -3172,6 +3093,7 @@
           <a:lstStyle xmlns:a="http://schemas.openxmlformats.org/drawingml/2006/main"/>
           <a:p xmlns:a="http://schemas.openxmlformats.org/drawingml/2006/main">
             <a:pPr algn="l">
+              <a:buNone/>
               <a:defRPr sz="2175" b="1">
                 <a:solidFill>
                   <a:srgbClr val="000000"/>
@@ -3222,6 +3144,7 @@
           <a:lstStyle xmlns:a="http://schemas.openxmlformats.org/drawingml/2006/main"/>
           <a:p xmlns:a="http://schemas.openxmlformats.org/drawingml/2006/main">
             <a:pPr algn="l">
+              <a:buNone/>
               <a:defRPr sz="1575" b="1">
                 <a:solidFill>
                   <a:srgbClr val="3D8DFF"/>
@@ -3272,6 +3195,7 @@
           <a:lstStyle xmlns:a="http://schemas.openxmlformats.org/drawingml/2006/main"/>
           <a:p xmlns:a="http://schemas.openxmlformats.org/drawingml/2006/main">
             <a:pPr algn="l">
+              <a:buNone/>
               <a:defRPr sz="1575" b="0">
                 <a:solidFill>
                   <a:srgbClr val="000000"/>
@@ -3322,6 +3246,7 @@
           <a:lstStyle xmlns:a="http://schemas.openxmlformats.org/drawingml/2006/main"/>
           <a:p xmlns:a="http://schemas.openxmlformats.org/drawingml/2006/main">
             <a:pPr algn="l">
+              <a:buNone/>
               <a:defRPr sz="1575" b="1">
                 <a:solidFill>
                   <a:srgbClr val="3D8DFF"/>
@@ -3372,6 +3297,7 @@
           <a:lstStyle xmlns:a="http://schemas.openxmlformats.org/drawingml/2006/main"/>
           <a:p xmlns:a="http://schemas.openxmlformats.org/drawingml/2006/main">
             <a:pPr algn="l">
+              <a:buNone/>
               <a:defRPr sz="1575" b="0">
                 <a:solidFill>
                   <a:srgbClr val="000000"/>
@@ -3422,6 +3348,7 @@
           <a:lstStyle xmlns:a="http://schemas.openxmlformats.org/drawingml/2006/main"/>
           <a:p xmlns:a="http://schemas.openxmlformats.org/drawingml/2006/main">
             <a:pPr algn="l">
+              <a:buNone/>
               <a:defRPr sz="1575" b="1">
                 <a:solidFill>
                   <a:srgbClr val="3D8DFF"/>
@@ -3472,6 +3399,7 @@
           <a:lstStyle xmlns:a="http://schemas.openxmlformats.org/drawingml/2006/main"/>
           <a:p xmlns:a="http://schemas.openxmlformats.org/drawingml/2006/main">
             <a:pPr algn="l">
+              <a:buNone/>
               <a:defRPr sz="1575" b="0">
                 <a:solidFill>
                   <a:srgbClr val="000000"/>
@@ -3522,6 +3450,7 @@
           <a:lstStyle xmlns:a="http://schemas.openxmlformats.org/drawingml/2006/main"/>
           <a:p xmlns:a="http://schemas.openxmlformats.org/drawingml/2006/main">
             <a:pPr algn="l">
+              <a:buNone/>
               <a:defRPr sz="1575" b="1">
                 <a:solidFill>
                   <a:srgbClr val="3D8DFF"/>
@@ -3572,6 +3501,7 @@
           <a:lstStyle xmlns:a="http://schemas.openxmlformats.org/drawingml/2006/main"/>
           <a:p xmlns:a="http://schemas.openxmlformats.org/drawingml/2006/main">
             <a:pPr algn="l">
+              <a:buNone/>
               <a:defRPr sz="1575" b="0">
                 <a:solidFill>
                   <a:srgbClr val="000000"/>
@@ -3622,6 +3552,7 @@
           <a:lstStyle xmlns:a="http://schemas.openxmlformats.org/drawingml/2006/main"/>
           <a:p xmlns:a="http://schemas.openxmlformats.org/drawingml/2006/main">
             <a:pPr algn="ctr">
+              <a:buNone/>
               <a:defRPr sz="2100" b="1">
                 <a:solidFill>
                   <a:srgbClr val="000000"/>
@@ -3672,6 +3603,7 @@
           <a:lstStyle xmlns:a="http://schemas.openxmlformats.org/drawingml/2006/main"/>
           <a:p xmlns:a="http://schemas.openxmlformats.org/drawingml/2006/main">
             <a:pPr algn="r">
+              <a:buNone/>
               <a:defRPr sz="975" b="0">
                 <a:solidFill>
                   <a:srgbClr val="60646C"/>
@@ -3744,6 +3676,7 @@
           <a:lstStyle xmlns:a="http://schemas.openxmlformats.org/drawingml/2006/main"/>
           <a:p xmlns:a="http://schemas.openxmlformats.org/drawingml/2006/main">
             <a:pPr algn="l">
+              <a:buNone/>
               <a:defRPr sz="1125" b="1">
                 <a:solidFill>
                   <a:srgbClr val="60646C"/>
@@ -3794,6 +3727,7 @@
           <a:lstStyle xmlns:a="http://schemas.openxmlformats.org/drawingml/2006/main"/>
           <a:p xmlns:a="http://schemas.openxmlformats.org/drawingml/2006/main">
             <a:pPr algn="l">
+              <a:buNone/>
               <a:defRPr sz="3750" b="1">
                 <a:solidFill>
                   <a:srgbClr val="000000"/>
@@ -3844,6 +3778,7 @@
           <a:lstStyle xmlns:a="http://schemas.openxmlformats.org/drawingml/2006/main"/>
           <a:p xmlns:a="http://schemas.openxmlformats.org/drawingml/2006/main">
             <a:pPr algn="l">
+              <a:buNone/>
               <a:defRPr sz="1725" b="0">
                 <a:solidFill>
                   <a:srgbClr val="60646C"/>
@@ -3927,6 +3862,7 @@
           <a:lstStyle xmlns:a="http://schemas.openxmlformats.org/drawingml/2006/main"/>
           <a:p xmlns:a="http://schemas.openxmlformats.org/drawingml/2006/main">
             <a:pPr algn="l">
+              <a:buNone/>
               <a:defRPr sz="2250" b="1">
                 <a:solidFill>
                   <a:srgbClr val="000000"/>
@@ -3977,6 +3913,7 @@
           <a:lstStyle xmlns:a="http://schemas.openxmlformats.org/drawingml/2006/main"/>
           <a:p xmlns:a="http://schemas.openxmlformats.org/drawingml/2006/main">
             <a:pPr algn="l">
+              <a:buNone/>
               <a:defRPr sz="1650" b="0">
                 <a:solidFill>
                   <a:srgbClr val="60646C"/>
@@ -4060,6 +3997,7 @@
           <a:lstStyle xmlns:a="http://schemas.openxmlformats.org/drawingml/2006/main"/>
           <a:p xmlns:a="http://schemas.openxmlformats.org/drawingml/2006/main">
             <a:pPr algn="l">
+              <a:buNone/>
               <a:defRPr sz="2250" b="1">
                 <a:solidFill>
                   <a:srgbClr val="000000"/>
@@ -4110,6 +4048,7 @@
           <a:lstStyle xmlns:a="http://schemas.openxmlformats.org/drawingml/2006/main"/>
           <a:p xmlns:a="http://schemas.openxmlformats.org/drawingml/2006/main">
             <a:pPr algn="l">
+              <a:buNone/>
               <a:defRPr sz="1650" b="0">
                 <a:solidFill>
                   <a:srgbClr val="60646C"/>
@@ -4193,6 +4132,7 @@
           <a:lstStyle xmlns:a="http://schemas.openxmlformats.org/drawingml/2006/main"/>
           <a:p xmlns:a="http://schemas.openxmlformats.org/drawingml/2006/main">
             <a:pPr algn="l">
+              <a:buNone/>
               <a:defRPr sz="2250" b="1">
                 <a:solidFill>
                   <a:srgbClr val="000000"/>
@@ -4243,6 +4183,7 @@
           <a:lstStyle xmlns:a="http://schemas.openxmlformats.org/drawingml/2006/main"/>
           <a:p xmlns:a="http://schemas.openxmlformats.org/drawingml/2006/main">
             <a:pPr algn="l">
+              <a:buNone/>
               <a:defRPr sz="1650" b="0">
                 <a:solidFill>
                   <a:srgbClr val="60646C"/>
@@ -4293,6 +4234,7 @@
           <a:lstStyle xmlns:a="http://schemas.openxmlformats.org/drawingml/2006/main"/>
           <a:p xmlns:a="http://schemas.openxmlformats.org/drawingml/2006/main">
             <a:pPr algn="r">
+              <a:buNone/>
               <a:defRPr sz="975" b="0">
                 <a:solidFill>
                   <a:srgbClr val="60646C"/>
@@ -4343,6 +4285,7 @@
           <a:lstStyle xmlns:a="http://schemas.openxmlformats.org/drawingml/2006/main"/>
           <a:p xmlns:a="http://schemas.openxmlformats.org/drawingml/2006/main">
             <a:pPr algn="l">
+              <a:buNone/>
               <a:defRPr sz="825" b="0">
                 <a:solidFill>
                   <a:srgbClr val="60646C"/>
@@ -4415,6 +4358,7 @@
           <a:lstStyle xmlns:a="http://schemas.openxmlformats.org/drawingml/2006/main"/>
           <a:p xmlns:a="http://schemas.openxmlformats.org/drawingml/2006/main">
             <a:pPr algn="l">
+              <a:buNone/>
               <a:defRPr sz="1125" b="1">
                 <a:solidFill>
                   <a:srgbClr val="60646C"/>
@@ -4465,6 +4409,7 @@
           <a:lstStyle xmlns:a="http://schemas.openxmlformats.org/drawingml/2006/main"/>
           <a:p xmlns:a="http://schemas.openxmlformats.org/drawingml/2006/main">
             <a:pPr algn="l">
+              <a:buNone/>
               <a:defRPr sz="3750" b="1">
                 <a:solidFill>
                   <a:srgbClr val="000000"/>
@@ -4548,6 +4493,7 @@
           <a:lstStyle xmlns:a="http://schemas.openxmlformats.org/drawingml/2006/main"/>
           <a:p xmlns:a="http://schemas.openxmlformats.org/drawingml/2006/main">
             <a:pPr algn="ctr">
+              <a:buNone/>
               <a:defRPr sz="2025" b="1">
                 <a:solidFill>
                   <a:srgbClr val="000000"/>
@@ -4598,6 +4544,7 @@
           <a:lstStyle xmlns:a="http://schemas.openxmlformats.org/drawingml/2006/main"/>
           <a:p xmlns:a="http://schemas.openxmlformats.org/drawingml/2006/main">
             <a:pPr algn="ctr">
+              <a:buNone/>
               <a:defRPr sz="1425" b="0">
                 <a:solidFill>
                   <a:srgbClr val="60646C"/>
@@ -4714,6 +4661,7 @@
           <a:lstStyle xmlns:a="http://schemas.openxmlformats.org/drawingml/2006/main"/>
           <a:p xmlns:a="http://schemas.openxmlformats.org/drawingml/2006/main">
             <a:pPr algn="ctr">
+              <a:buNone/>
               <a:defRPr sz="2025" b="1">
                 <a:solidFill>
                   <a:srgbClr val="000000"/>
@@ -4764,6 +4712,7 @@
           <a:lstStyle xmlns:a="http://schemas.openxmlformats.org/drawingml/2006/main"/>
           <a:p xmlns:a="http://schemas.openxmlformats.org/drawingml/2006/main">
             <a:pPr algn="ctr">
+              <a:buNone/>
               <a:defRPr sz="1425" b="0">
                 <a:solidFill>
                   <a:srgbClr val="60646C"/>
@@ -4880,6 +4829,7 @@
           <a:lstStyle xmlns:a="http://schemas.openxmlformats.org/drawingml/2006/main"/>
           <a:p xmlns:a="http://schemas.openxmlformats.org/drawingml/2006/main">
             <a:pPr algn="ctr">
+              <a:buNone/>
               <a:defRPr sz="2025" b="1">
                 <a:solidFill>
                   <a:srgbClr val="000000"/>
@@ -4930,6 +4880,7 @@
           <a:lstStyle xmlns:a="http://schemas.openxmlformats.org/drawingml/2006/main"/>
           <a:p xmlns:a="http://schemas.openxmlformats.org/drawingml/2006/main">
             <a:pPr algn="ctr">
+              <a:buNone/>
               <a:defRPr sz="1425" b="0">
                 <a:solidFill>
                   <a:srgbClr val="60646C"/>
@@ -5046,6 +4997,7 @@
           <a:lstStyle xmlns:a="http://schemas.openxmlformats.org/drawingml/2006/main"/>
           <a:p xmlns:a="http://schemas.openxmlformats.org/drawingml/2006/main">
             <a:pPr algn="ctr">
+              <a:buNone/>
               <a:defRPr sz="2025" b="1">
                 <a:solidFill>
                   <a:srgbClr val="000000"/>
@@ -5096,6 +5048,7 @@
           <a:lstStyle xmlns:a="http://schemas.openxmlformats.org/drawingml/2006/main"/>
           <a:p xmlns:a="http://schemas.openxmlformats.org/drawingml/2006/main">
             <a:pPr algn="ctr">
+              <a:buNone/>
               <a:defRPr sz="1425" b="0">
                 <a:solidFill>
                   <a:srgbClr val="60646C"/>
@@ -5146,6 +5099,7 @@
           <a:lstStyle xmlns:a="http://schemas.openxmlformats.org/drawingml/2006/main"/>
           <a:p xmlns:a="http://schemas.openxmlformats.org/drawingml/2006/main">
             <a:pPr algn="ctr">
+              <a:buNone/>
               <a:defRPr sz="2175" b="1">
                 <a:solidFill>
                   <a:srgbClr val="000000"/>
@@ -5196,6 +5150,7 @@
           <a:lstStyle xmlns:a="http://schemas.openxmlformats.org/drawingml/2006/main"/>
           <a:p xmlns:a="http://schemas.openxmlformats.org/drawingml/2006/main">
             <a:pPr algn="r">
+              <a:buNone/>
               <a:defRPr sz="975" b="0">
                 <a:solidFill>
                   <a:srgbClr val="60646C"/>
@@ -5268,6 +5223,7 @@
           <a:lstStyle xmlns:a="http://schemas.openxmlformats.org/drawingml/2006/main"/>
           <a:p xmlns:a="http://schemas.openxmlformats.org/drawingml/2006/main">
             <a:pPr algn="l">
+              <a:buNone/>
               <a:defRPr sz="1125" b="1">
                 <a:solidFill>
                   <a:srgbClr val="60646C"/>
@@ -5318,6 +5274,7 @@
           <a:lstStyle xmlns:a="http://schemas.openxmlformats.org/drawingml/2006/main"/>
           <a:p xmlns:a="http://schemas.openxmlformats.org/drawingml/2006/main">
             <a:pPr algn="l">
+              <a:buNone/>
               <a:defRPr sz="3750" b="1">
                 <a:solidFill>
                   <a:srgbClr val="000000"/>
@@ -5399,6 +5356,7 @@
           <a:lstStyle xmlns:a="http://schemas.openxmlformats.org/drawingml/2006/main"/>
           <a:p xmlns:a="http://schemas.openxmlformats.org/drawingml/2006/main">
             <a:pPr algn="l">
+              <a:buNone/>
               <a:defRPr sz="1800" b="1">
                 <a:solidFill>
                   <a:srgbClr val="3D8DFF"/>
@@ -5449,6 +5407,7 @@
           <a:lstStyle xmlns:a="http://schemas.openxmlformats.org/drawingml/2006/main"/>
           <a:p xmlns:a="http://schemas.openxmlformats.org/drawingml/2006/main">
             <a:pPr algn="l">
+              <a:buNone/>
               <a:defRPr sz="1800" b="1">
                 <a:solidFill>
                   <a:srgbClr val="000000"/>
@@ -5499,6 +5458,7 @@
           <a:lstStyle xmlns:a="http://schemas.openxmlformats.org/drawingml/2006/main"/>
           <a:p xmlns:a="http://schemas.openxmlformats.org/drawingml/2006/main">
             <a:pPr algn="l">
+              <a:buNone/>
               <a:defRPr sz="1575" b="0">
                 <a:solidFill>
                   <a:srgbClr val="60646C"/>
@@ -5580,6 +5540,7 @@
           <a:lstStyle xmlns:a="http://schemas.openxmlformats.org/drawingml/2006/main"/>
           <a:p xmlns:a="http://schemas.openxmlformats.org/drawingml/2006/main">
             <a:pPr algn="l">
+              <a:buNone/>
               <a:defRPr sz="1800" b="1">
                 <a:solidFill>
                   <a:srgbClr val="3D8DFF"/>
@@ -5630,6 +5591,7 @@
           <a:lstStyle xmlns:a="http://schemas.openxmlformats.org/drawingml/2006/main"/>
           <a:p xmlns:a="http://schemas.openxmlformats.org/drawingml/2006/main">
             <a:pPr algn="l">
+              <a:buNone/>
               <a:defRPr sz="1800" b="1">
                 <a:solidFill>
                   <a:srgbClr val="000000"/>
@@ -5680,6 +5642,7 @@
           <a:lstStyle xmlns:a="http://schemas.openxmlformats.org/drawingml/2006/main"/>
           <a:p xmlns:a="http://schemas.openxmlformats.org/drawingml/2006/main">
             <a:pPr algn="l">
+              <a:buNone/>
               <a:defRPr sz="1575" b="0">
                 <a:solidFill>
                   <a:srgbClr val="60646C"/>
@@ -5761,6 +5724,7 @@
           <a:lstStyle xmlns:a="http://schemas.openxmlformats.org/drawingml/2006/main"/>
           <a:p xmlns:a="http://schemas.openxmlformats.org/drawingml/2006/main">
             <a:pPr algn="l">
+              <a:buNone/>
               <a:defRPr sz="1800" b="1">
                 <a:solidFill>
                   <a:srgbClr val="3D8DFF"/>
@@ -5811,6 +5775,7 @@
           <a:lstStyle xmlns:a="http://schemas.openxmlformats.org/drawingml/2006/main"/>
           <a:p xmlns:a="http://schemas.openxmlformats.org/drawingml/2006/main">
             <a:pPr algn="l">
+              <a:buNone/>
               <a:defRPr sz="1800" b="1">
                 <a:solidFill>
                   <a:srgbClr val="000000"/>
@@ -5861,6 +5826,7 @@
           <a:lstStyle xmlns:a="http://schemas.openxmlformats.org/drawingml/2006/main"/>
           <a:p xmlns:a="http://schemas.openxmlformats.org/drawingml/2006/main">
             <a:pPr algn="l">
+              <a:buNone/>
               <a:defRPr sz="1575" b="0">
                 <a:solidFill>
                   <a:srgbClr val="60646C"/>
@@ -5942,6 +5908,7 @@
           <a:lstStyle xmlns:a="http://schemas.openxmlformats.org/drawingml/2006/main"/>
           <a:p xmlns:a="http://schemas.openxmlformats.org/drawingml/2006/main">
             <a:pPr algn="l">
+              <a:buNone/>
               <a:defRPr sz="1800" b="1">
                 <a:solidFill>
                   <a:srgbClr val="3D8DFF"/>
@@ -5992,6 +5959,7 @@
           <a:lstStyle xmlns:a="http://schemas.openxmlformats.org/drawingml/2006/main"/>
           <a:p xmlns:a="http://schemas.openxmlformats.org/drawingml/2006/main">
             <a:pPr algn="l">
+              <a:buNone/>
               <a:defRPr sz="1800" b="1">
                 <a:solidFill>
                   <a:srgbClr val="000000"/>
@@ -6042,6 +6010,7 @@
           <a:lstStyle xmlns:a="http://schemas.openxmlformats.org/drawingml/2006/main"/>
           <a:p xmlns:a="http://schemas.openxmlformats.org/drawingml/2006/main">
             <a:pPr algn="l">
+              <a:buNone/>
               <a:defRPr sz="1575" b="0">
                 <a:solidFill>
                   <a:srgbClr val="60646C"/>
@@ -6123,6 +6092,7 @@
           <a:lstStyle xmlns:a="http://schemas.openxmlformats.org/drawingml/2006/main"/>
           <a:p xmlns:a="http://schemas.openxmlformats.org/drawingml/2006/main">
             <a:pPr algn="l">
+              <a:buNone/>
               <a:defRPr sz="1800" b="1">
                 <a:solidFill>
                   <a:srgbClr val="3D8DFF"/>
@@ -6173,6 +6143,7 @@
           <a:lstStyle xmlns:a="http://schemas.openxmlformats.org/drawingml/2006/main"/>
           <a:p xmlns:a="http://schemas.openxmlformats.org/drawingml/2006/main">
             <a:pPr algn="l">
+              <a:buNone/>
               <a:defRPr sz="1800" b="1">
                 <a:solidFill>
                   <a:srgbClr val="000000"/>
@@ -6223,6 +6194,7 @@
           <a:lstStyle xmlns:a="http://schemas.openxmlformats.org/drawingml/2006/main"/>
           <a:p xmlns:a="http://schemas.openxmlformats.org/drawingml/2006/main">
             <a:pPr algn="l">
+              <a:buNone/>
               <a:defRPr sz="1575" b="0">
                 <a:solidFill>
                   <a:srgbClr val="60646C"/>
@@ -6288,35 +6260,39 @@
         <p:spPr>
           <a:xfrm xmlns:a="http://schemas.openxmlformats.org/drawingml/2006/main">
             <a:off x="914400" y="4810125"/>
-            <a:ext cx="666750" cy="323850"/>
-          </a:xfrm>
-          <a:prstGeom xmlns:a="http://schemas.openxmlformats.org/drawingml/2006/main" prst="rect">
-            <a:avLst/>
-          </a:prstGeom>
-          <a:noFill xmlns:a="http://schemas.openxmlformats.org/drawingml/2006/main"/>
-          <a:ln xmlns:a="http://schemas.openxmlformats.org/drawingml/2006/main" w="0">
-            <a:noFill/>
-            <a:prstDash val="solid"/>
-          </a:ln>
-        </p:spPr>
-        <p:txBody>
-          <a:bodyPr xmlns:a="http://schemas.openxmlformats.org/drawingml/2006/main"/>
-          <a:lstStyle xmlns:a="http://schemas.openxmlformats.org/drawingml/2006/main"/>
-          <a:p xmlns:a="http://schemas.openxmlformats.org/drawingml/2006/main">
-            <a:pPr algn="l">
-              <a:defRPr sz="1800" b="1">
+            <a:ext cx="781050" cy="323850"/>
+          </a:xfrm>
+          <a:prstGeom xmlns:a="http://schemas.openxmlformats.org/drawingml/2006/main" prst="rect">
+            <a:avLst/>
+          </a:prstGeom>
+          <a:noFill xmlns:a="http://schemas.openxmlformats.org/drawingml/2006/main"/>
+          <a:ln xmlns:a="http://schemas.openxmlformats.org/drawingml/2006/main" w="0">
+            <a:noFill/>
+            <a:prstDash val="solid"/>
+          </a:ln>
+        </p:spPr>
+        <p:txBody>
+          <a:bodyPr xmlns:a="http://schemas.openxmlformats.org/drawingml/2006/main"/>
+          <a:lstStyle xmlns:a="http://schemas.openxmlformats.org/drawingml/2006/main"/>
+          <a:p xmlns:a="http://schemas.openxmlformats.org/drawingml/2006/main">
+            <a:pPr algn="l">
+              <a:lnSpc>
+                <a:spcPct val="106000"/>
+              </a:lnSpc>
+              <a:buNone/>
+              <a:defRPr sz="1200" b="1">
                 <a:solidFill>
                   <a:srgbClr val="3D8DFF"/>
                 </a:solidFill>
               </a:defRPr>
             </a:pPr>
             <a:r>
-              <a:rPr sz="1800" b="1">
+              <a:rPr sz="1200" b="1">
                 <a:solidFill>
                   <a:srgbClr val="3D8DFF"/>
                 </a:solidFill>
               </a:rPr>
-              <a:t>05</a:t>
+              <a:t>05A/B</a:t>
             </a:r>
           </a:p>
         </p:txBody>
@@ -6354,19 +6330,23 @@
           <a:lstStyle xmlns:a="http://schemas.openxmlformats.org/drawingml/2006/main"/>
           <a:p xmlns:a="http://schemas.openxmlformats.org/drawingml/2006/main">
             <a:pPr algn="l">
-              <a:defRPr sz="1800" b="1">
-                <a:solidFill>
-                  <a:srgbClr val="000000"/>
-                </a:solidFill>
-              </a:defRPr>
-            </a:pPr>
-            <a:r>
-              <a:rPr sz="1800" b="1">
-                <a:solidFill>
-                  <a:srgbClr val="000000"/>
-                </a:solidFill>
-              </a:rPr>
-              <a:t>Skills</a:t>
+              <a:lnSpc>
+                <a:spcPct val="108000"/>
+              </a:lnSpc>
+              <a:buNone/>
+              <a:defRPr sz="1575" b="1">
+                <a:solidFill>
+                  <a:srgbClr val="000000"/>
+                </a:solidFill>
+              </a:defRPr>
+            </a:pPr>
+            <a:r>
+              <a:rPr sz="1575" b="1">
+                <a:solidFill>
+                  <a:srgbClr val="000000"/>
+                </a:solidFill>
+              </a:rPr>
+              <a:t>Capabilities</a:t>
             </a:r>
           </a:p>
         </p:txBody>
@@ -6404,19 +6384,23 @@
           <a:lstStyle xmlns:a="http://schemas.openxmlformats.org/drawingml/2006/main"/>
           <a:p xmlns:a="http://schemas.openxmlformats.org/drawingml/2006/main">
             <a:pPr algn="l">
-              <a:defRPr sz="1575" b="0">
+              <a:lnSpc>
+                <a:spcPct val="108000"/>
+              </a:lnSpc>
+              <a:buNone/>
+              <a:defRPr sz="1575" b="1">
                 <a:solidFill>
                   <a:srgbClr val="60646C"/>
                 </a:solidFill>
               </a:defRPr>
             </a:pPr>
             <a:r>
-              <a:rPr sz="1575" b="0">
+              <a:rPr sz="1575" b="1">
                 <a:solidFill>
                   <a:srgbClr val="60646C"/>
                 </a:solidFill>
               </a:rPr>
-              <a:t>reusable context as organizational IP</a:t>
+              <a:t>scout, evaluate, publish, and maintain skills + agents</a:t>
             </a:r>
           </a:p>
         </p:txBody>
@@ -6485,19 +6469,23 @@
           <a:lstStyle xmlns:a="http://schemas.openxmlformats.org/drawingml/2006/main"/>
           <a:p xmlns:a="http://schemas.openxmlformats.org/drawingml/2006/main">
             <a:pPr algn="l">
-              <a:defRPr sz="1800" b="1">
+              <a:lnSpc>
+                <a:spcPct val="108000"/>
+              </a:lnSpc>
+              <a:buNone/>
+              <a:defRPr sz="1575" b="1">
                 <a:solidFill>
                   <a:srgbClr val="3D8DFF"/>
                 </a:solidFill>
               </a:defRPr>
             </a:pPr>
             <a:r>
-              <a:rPr sz="1800" b="1">
+              <a:rPr sz="1575" b="1">
                 <a:solidFill>
                   <a:srgbClr val="3D8DFF"/>
                 </a:solidFill>
               </a:rPr>
-              <a:t>06</a:t>
+              <a:t>06 / 07</a:t>
             </a:r>
           </a:p>
         </p:txBody>
@@ -6535,19 +6523,23 @@
           <a:lstStyle xmlns:a="http://schemas.openxmlformats.org/drawingml/2006/main"/>
           <a:p xmlns:a="http://schemas.openxmlformats.org/drawingml/2006/main">
             <a:pPr algn="l">
-              <a:defRPr sz="1800" b="1">
-                <a:solidFill>
-                  <a:srgbClr val="000000"/>
-                </a:solidFill>
-              </a:defRPr>
-            </a:pPr>
-            <a:r>
-              <a:rPr sz="1800" b="1">
-                <a:solidFill>
-                  <a:srgbClr val="000000"/>
-                </a:solidFill>
-              </a:rPr>
-              <a:t>Evals</a:t>
+              <a:lnSpc>
+                <a:spcPct val="108000"/>
+              </a:lnSpc>
+              <a:buNone/>
+              <a:defRPr sz="1575" b="1">
+                <a:solidFill>
+                  <a:srgbClr val="000000"/>
+                </a:solidFill>
+              </a:defRPr>
+            </a:pPr>
+            <a:r>
+              <a:rPr sz="1575" b="1">
+                <a:solidFill>
+                  <a:srgbClr val="000000"/>
+                </a:solidFill>
+              </a:rPr>
+              <a:t>Evals / AI Program</a:t>
             </a:r>
           </a:p>
         </p:txBody>
@@ -6585,19 +6577,23 @@
           <a:lstStyle xmlns:a="http://schemas.openxmlformats.org/drawingml/2006/main"/>
           <a:p xmlns:a="http://schemas.openxmlformats.org/drawingml/2006/main">
             <a:pPr algn="l">
-              <a:defRPr sz="1575" b="0">
+              <a:lnSpc>
+                <a:spcPct val="108000"/>
+              </a:lnSpc>
+              <a:buNone/>
+              <a:defRPr sz="1425" b="0">
                 <a:solidFill>
                   <a:srgbClr val="60646C"/>
                 </a:solidFill>
               </a:defRPr>
             </a:pPr>
             <a:r>
-              <a:rPr sz="1575" b="0">
+              <a:rPr sz="1425" b="0">
                 <a:solidFill>
                   <a:srgbClr val="60646C"/>
                 </a:solidFill>
               </a:rPr>
-              <a:t>model routing, quality, cost, procurement</a:t>
+              <a:t>model routing, then owned governance + GRC</a:t>
             </a:r>
           </a:p>
         </p:txBody>
@@ -6635,6 +6631,7 @@
           <a:lstStyle xmlns:a="http://schemas.openxmlformats.org/drawingml/2006/main"/>
           <a:p xmlns:a="http://schemas.openxmlformats.org/drawingml/2006/main">
             <a:pPr algn="r">
+              <a:buNone/>
               <a:defRPr sz="975" b="0">
                 <a:solidFill>
                   <a:srgbClr val="60646C"/>
@@ -6707,6 +6704,7 @@
           <a:lstStyle xmlns:a="http://schemas.openxmlformats.org/drawingml/2006/main"/>
           <a:p xmlns:a="http://schemas.openxmlformats.org/drawingml/2006/main">
             <a:pPr algn="l">
+              <a:buNone/>
               <a:defRPr sz="1125" b="1">
                 <a:solidFill>
                   <a:srgbClr val="60646C"/>
@@ -6757,14 +6755,18 @@
           <a:lstStyle xmlns:a="http://schemas.openxmlformats.org/drawingml/2006/main"/>
           <a:p xmlns:a="http://schemas.openxmlformats.org/drawingml/2006/main">
             <a:pPr algn="l">
-              <a:defRPr sz="3750" b="1">
-                <a:solidFill>
-                  <a:srgbClr val="000000"/>
-                </a:solidFill>
-              </a:defRPr>
-            </a:pPr>
-            <a:r>
-              <a:rPr sz="3750" b="1">
+              <a:lnSpc>
+                <a:spcPct val="98000"/>
+              </a:lnSpc>
+              <a:buNone/>
+              <a:defRPr sz="3300" b="1">
+                <a:solidFill>
+                  <a:srgbClr val="000000"/>
+                </a:solidFill>
+              </a:defRPr>
+            </a:pPr>
+            <a:r>
+              <a:rPr sz="3300" b="1">
                 <a:solidFill>
                   <a:srgbClr val="000000"/>
                 </a:solidFill>
@@ -6840,6 +6842,7 @@
           <a:lstStyle xmlns:a="http://schemas.openxmlformats.org/drawingml/2006/main"/>
           <a:p xmlns:a="http://schemas.openxmlformats.org/drawingml/2006/main">
             <a:pPr algn="l">
+              <a:buNone/>
               <a:defRPr sz="2250" b="1">
                 <a:solidFill>
                   <a:srgbClr val="000000"/>
@@ -6873,23 +6876,24 @@
         </p:nvSpPr>
         <p:spPr>
           <a:xfrm xmlns:a="http://schemas.openxmlformats.org/drawingml/2006/main">
-            <a:off x="1200150" y="3857625"/>
-            <a:ext cx="209550" cy="266700"/>
-          </a:xfrm>
-          <a:prstGeom xmlns:a="http://schemas.openxmlformats.org/drawingml/2006/main" prst="rect">
-            <a:avLst/>
-          </a:prstGeom>
-          <a:noFill xmlns:a="http://schemas.openxmlformats.org/drawingml/2006/main"/>
-          <a:ln xmlns:a="http://schemas.openxmlformats.org/drawingml/2006/main" w="0">
-            <a:noFill/>
-            <a:prstDash val="solid"/>
-          </a:ln>
-        </p:spPr>
-        <p:txBody>
-          <a:bodyPr xmlns:a="http://schemas.openxmlformats.org/drawingml/2006/main"/>
-          <a:lstStyle xmlns:a="http://schemas.openxmlformats.org/drawingml/2006/main"/>
-          <a:p xmlns:a="http://schemas.openxmlformats.org/drawingml/2006/main">
-            <a:pPr algn="l">
+            <a:off x="1200150" y="3790950"/>
+            <a:ext cx="209550" cy="228600"/>
+          </a:xfrm>
+          <a:prstGeom xmlns:a="http://schemas.openxmlformats.org/drawingml/2006/main" prst="rect">
+            <a:avLst/>
+          </a:prstGeom>
+          <a:noFill xmlns:a="http://schemas.openxmlformats.org/drawingml/2006/main"/>
+          <a:ln xmlns:a="http://schemas.openxmlformats.org/drawingml/2006/main" w="0">
+            <a:noFill/>
+            <a:prstDash val="solid"/>
+          </a:ln>
+        </p:spPr>
+        <p:txBody>
+          <a:bodyPr xmlns:a="http://schemas.openxmlformats.org/drawingml/2006/main"/>
+          <a:lstStyle xmlns:a="http://schemas.openxmlformats.org/drawingml/2006/main"/>
+          <a:p xmlns:a="http://schemas.openxmlformats.org/drawingml/2006/main">
+            <a:pPr algn="l">
+              <a:buNone/>
               <a:defRPr sz="1575" b="1">
                 <a:solidFill>
                   <a:srgbClr val="3D8DFF"/>
@@ -6923,31 +6927,35 @@
         </p:nvSpPr>
         <p:spPr>
           <a:xfrm xmlns:a="http://schemas.openxmlformats.org/drawingml/2006/main">
-            <a:off x="1524000" y="3857625"/>
-            <a:ext cx="3105150" cy="323850"/>
-          </a:xfrm>
-          <a:prstGeom xmlns:a="http://schemas.openxmlformats.org/drawingml/2006/main" prst="rect">
-            <a:avLst/>
-          </a:prstGeom>
-          <a:noFill xmlns:a="http://schemas.openxmlformats.org/drawingml/2006/main"/>
-          <a:ln xmlns:a="http://schemas.openxmlformats.org/drawingml/2006/main" w="0">
-            <a:noFill/>
-            <a:prstDash val="solid"/>
-          </a:ln>
-        </p:spPr>
-        <p:txBody>
-          <a:bodyPr xmlns:a="http://schemas.openxmlformats.org/drawingml/2006/main"/>
-          <a:lstStyle xmlns:a="http://schemas.openxmlformats.org/drawingml/2006/main"/>
-          <a:p xmlns:a="http://schemas.openxmlformats.org/drawingml/2006/main">
-            <a:pPr algn="l">
-              <a:defRPr sz="1575" b="0">
-                <a:solidFill>
-                  <a:srgbClr val="000000"/>
-                </a:solidFill>
-              </a:defRPr>
-            </a:pPr>
-            <a:r>
-              <a:rPr sz="1575" b="0">
+            <a:off x="1524000" y="3790950"/>
+            <a:ext cx="3105150" cy="266700"/>
+          </a:xfrm>
+          <a:prstGeom xmlns:a="http://schemas.openxmlformats.org/drawingml/2006/main" prst="rect">
+            <a:avLst/>
+          </a:prstGeom>
+          <a:noFill xmlns:a="http://schemas.openxmlformats.org/drawingml/2006/main"/>
+          <a:ln xmlns:a="http://schemas.openxmlformats.org/drawingml/2006/main" w="0">
+            <a:noFill/>
+            <a:prstDash val="solid"/>
+          </a:ln>
+        </p:spPr>
+        <p:txBody>
+          <a:bodyPr xmlns:a="http://schemas.openxmlformats.org/drawingml/2006/main"/>
+          <a:lstStyle xmlns:a="http://schemas.openxmlformats.org/drawingml/2006/main"/>
+          <a:p xmlns:a="http://schemas.openxmlformats.org/drawingml/2006/main">
+            <a:pPr algn="l">
+              <a:lnSpc>
+                <a:spcPct val="106000"/>
+              </a:lnSpc>
+              <a:buNone/>
+              <a:defRPr sz="1350" b="0">
+                <a:solidFill>
+                  <a:srgbClr val="000000"/>
+                </a:solidFill>
+              </a:defRPr>
+            </a:pPr>
+            <a:r>
+              <a:rPr sz="1350" b="0">
                 <a:solidFill>
                   <a:srgbClr val="000000"/>
                 </a:solidFill>
@@ -6973,23 +6981,24 @@
         </p:nvSpPr>
         <p:spPr>
           <a:xfrm xmlns:a="http://schemas.openxmlformats.org/drawingml/2006/main">
-            <a:off x="1200150" y="4162425"/>
-            <a:ext cx="209550" cy="266700"/>
-          </a:xfrm>
-          <a:prstGeom xmlns:a="http://schemas.openxmlformats.org/drawingml/2006/main" prst="rect">
-            <a:avLst/>
-          </a:prstGeom>
-          <a:noFill xmlns:a="http://schemas.openxmlformats.org/drawingml/2006/main"/>
-          <a:ln xmlns:a="http://schemas.openxmlformats.org/drawingml/2006/main" w="0">
-            <a:noFill/>
-            <a:prstDash val="solid"/>
-          </a:ln>
-        </p:spPr>
-        <p:txBody>
-          <a:bodyPr xmlns:a="http://schemas.openxmlformats.org/drawingml/2006/main"/>
-          <a:lstStyle xmlns:a="http://schemas.openxmlformats.org/drawingml/2006/main"/>
-          <a:p xmlns:a="http://schemas.openxmlformats.org/drawingml/2006/main">
-            <a:pPr algn="l">
+            <a:off x="1200150" y="4095750"/>
+            <a:ext cx="209550" cy="228600"/>
+          </a:xfrm>
+          <a:prstGeom xmlns:a="http://schemas.openxmlformats.org/drawingml/2006/main" prst="rect">
+            <a:avLst/>
+          </a:prstGeom>
+          <a:noFill xmlns:a="http://schemas.openxmlformats.org/drawingml/2006/main"/>
+          <a:ln xmlns:a="http://schemas.openxmlformats.org/drawingml/2006/main" w="0">
+            <a:noFill/>
+            <a:prstDash val="solid"/>
+          </a:ln>
+        </p:spPr>
+        <p:txBody>
+          <a:bodyPr xmlns:a="http://schemas.openxmlformats.org/drawingml/2006/main"/>
+          <a:lstStyle xmlns:a="http://schemas.openxmlformats.org/drawingml/2006/main"/>
+          <a:p xmlns:a="http://schemas.openxmlformats.org/drawingml/2006/main">
+            <a:pPr algn="l">
+              <a:buNone/>
               <a:defRPr sz="1575" b="1">
                 <a:solidFill>
                   <a:srgbClr val="3D8DFF"/>
@@ -7023,31 +7032,35 @@
         </p:nvSpPr>
         <p:spPr>
           <a:xfrm xmlns:a="http://schemas.openxmlformats.org/drawingml/2006/main">
-            <a:off x="1524000" y="4162425"/>
-            <a:ext cx="3105150" cy="323850"/>
-          </a:xfrm>
-          <a:prstGeom xmlns:a="http://schemas.openxmlformats.org/drawingml/2006/main" prst="rect">
-            <a:avLst/>
-          </a:prstGeom>
-          <a:noFill xmlns:a="http://schemas.openxmlformats.org/drawingml/2006/main"/>
-          <a:ln xmlns:a="http://schemas.openxmlformats.org/drawingml/2006/main" w="0">
-            <a:noFill/>
-            <a:prstDash val="solid"/>
-          </a:ln>
-        </p:spPr>
-        <p:txBody>
-          <a:bodyPr xmlns:a="http://schemas.openxmlformats.org/drawingml/2006/main"/>
-          <a:lstStyle xmlns:a="http://schemas.openxmlformats.org/drawingml/2006/main"/>
-          <a:p xmlns:a="http://schemas.openxmlformats.org/drawingml/2006/main">
-            <a:pPr algn="l">
-              <a:defRPr sz="1575" b="0">
-                <a:solidFill>
-                  <a:srgbClr val="000000"/>
-                </a:solidFill>
-              </a:defRPr>
-            </a:pPr>
-            <a:r>
-              <a:rPr sz="1575" b="0">
+            <a:off x="1524000" y="4095750"/>
+            <a:ext cx="3105150" cy="266700"/>
+          </a:xfrm>
+          <a:prstGeom xmlns:a="http://schemas.openxmlformats.org/drawingml/2006/main" prst="rect">
+            <a:avLst/>
+          </a:prstGeom>
+          <a:noFill xmlns:a="http://schemas.openxmlformats.org/drawingml/2006/main"/>
+          <a:ln xmlns:a="http://schemas.openxmlformats.org/drawingml/2006/main" w="0">
+            <a:noFill/>
+            <a:prstDash val="solid"/>
+          </a:ln>
+        </p:spPr>
+        <p:txBody>
+          <a:bodyPr xmlns:a="http://schemas.openxmlformats.org/drawingml/2006/main"/>
+          <a:lstStyle xmlns:a="http://schemas.openxmlformats.org/drawingml/2006/main"/>
+          <a:p xmlns:a="http://schemas.openxmlformats.org/drawingml/2006/main">
+            <a:pPr algn="l">
+              <a:lnSpc>
+                <a:spcPct val="106000"/>
+              </a:lnSpc>
+              <a:buNone/>
+              <a:defRPr sz="1350" b="0">
+                <a:solidFill>
+                  <a:srgbClr val="000000"/>
+                </a:solidFill>
+              </a:defRPr>
+            </a:pPr>
+            <a:r>
+              <a:rPr sz="1350" b="0">
                 <a:solidFill>
                   <a:srgbClr val="000000"/>
                 </a:solidFill>
@@ -7073,23 +7086,24 @@
         </p:nvSpPr>
         <p:spPr>
           <a:xfrm xmlns:a="http://schemas.openxmlformats.org/drawingml/2006/main">
-            <a:off x="1200150" y="4467225"/>
-            <a:ext cx="209550" cy="266700"/>
-          </a:xfrm>
-          <a:prstGeom xmlns:a="http://schemas.openxmlformats.org/drawingml/2006/main" prst="rect">
-            <a:avLst/>
-          </a:prstGeom>
-          <a:noFill xmlns:a="http://schemas.openxmlformats.org/drawingml/2006/main"/>
-          <a:ln xmlns:a="http://schemas.openxmlformats.org/drawingml/2006/main" w="0">
-            <a:noFill/>
-            <a:prstDash val="solid"/>
-          </a:ln>
-        </p:spPr>
-        <p:txBody>
-          <a:bodyPr xmlns:a="http://schemas.openxmlformats.org/drawingml/2006/main"/>
-          <a:lstStyle xmlns:a="http://schemas.openxmlformats.org/drawingml/2006/main"/>
-          <a:p xmlns:a="http://schemas.openxmlformats.org/drawingml/2006/main">
-            <a:pPr algn="l">
+            <a:off x="1200150" y="4400550"/>
+            <a:ext cx="209550" cy="228600"/>
+          </a:xfrm>
+          <a:prstGeom xmlns:a="http://schemas.openxmlformats.org/drawingml/2006/main" prst="rect">
+            <a:avLst/>
+          </a:prstGeom>
+          <a:noFill xmlns:a="http://schemas.openxmlformats.org/drawingml/2006/main"/>
+          <a:ln xmlns:a="http://schemas.openxmlformats.org/drawingml/2006/main" w="0">
+            <a:noFill/>
+            <a:prstDash val="solid"/>
+          </a:ln>
+        </p:spPr>
+        <p:txBody>
+          <a:bodyPr xmlns:a="http://schemas.openxmlformats.org/drawingml/2006/main"/>
+          <a:lstStyle xmlns:a="http://schemas.openxmlformats.org/drawingml/2006/main"/>
+          <a:p xmlns:a="http://schemas.openxmlformats.org/drawingml/2006/main">
+            <a:pPr algn="l">
+              <a:buNone/>
               <a:defRPr sz="1575" b="1">
                 <a:solidFill>
                   <a:srgbClr val="3D8DFF"/>
@@ -7123,31 +7137,35 @@
         </p:nvSpPr>
         <p:spPr>
           <a:xfrm xmlns:a="http://schemas.openxmlformats.org/drawingml/2006/main">
-            <a:off x="1524000" y="4467225"/>
-            <a:ext cx="3105150" cy="323850"/>
-          </a:xfrm>
-          <a:prstGeom xmlns:a="http://schemas.openxmlformats.org/drawingml/2006/main" prst="rect">
-            <a:avLst/>
-          </a:prstGeom>
-          <a:noFill xmlns:a="http://schemas.openxmlformats.org/drawingml/2006/main"/>
-          <a:ln xmlns:a="http://schemas.openxmlformats.org/drawingml/2006/main" w="0">
-            <a:noFill/>
-            <a:prstDash val="solid"/>
-          </a:ln>
-        </p:spPr>
-        <p:txBody>
-          <a:bodyPr xmlns:a="http://schemas.openxmlformats.org/drawingml/2006/main"/>
-          <a:lstStyle xmlns:a="http://schemas.openxmlformats.org/drawingml/2006/main"/>
-          <a:p xmlns:a="http://schemas.openxmlformats.org/drawingml/2006/main">
-            <a:pPr algn="l">
-              <a:defRPr sz="1575" b="0">
-                <a:solidFill>
-                  <a:srgbClr val="000000"/>
-                </a:solidFill>
-              </a:defRPr>
-            </a:pPr>
-            <a:r>
-              <a:rPr sz="1575" b="0">
+            <a:off x="1524000" y="4400550"/>
+            <a:ext cx="3105150" cy="266700"/>
+          </a:xfrm>
+          <a:prstGeom xmlns:a="http://schemas.openxmlformats.org/drawingml/2006/main" prst="rect">
+            <a:avLst/>
+          </a:prstGeom>
+          <a:noFill xmlns:a="http://schemas.openxmlformats.org/drawingml/2006/main"/>
+          <a:ln xmlns:a="http://schemas.openxmlformats.org/drawingml/2006/main" w="0">
+            <a:noFill/>
+            <a:prstDash val="solid"/>
+          </a:ln>
+        </p:spPr>
+        <p:txBody>
+          <a:bodyPr xmlns:a="http://schemas.openxmlformats.org/drawingml/2006/main"/>
+          <a:lstStyle xmlns:a="http://schemas.openxmlformats.org/drawingml/2006/main"/>
+          <a:p xmlns:a="http://schemas.openxmlformats.org/drawingml/2006/main">
+            <a:pPr algn="l">
+              <a:lnSpc>
+                <a:spcPct val="106000"/>
+              </a:lnSpc>
+              <a:buNone/>
+              <a:defRPr sz="1350" b="0">
+                <a:solidFill>
+                  <a:srgbClr val="000000"/>
+                </a:solidFill>
+              </a:defRPr>
+            </a:pPr>
+            <a:r>
+              <a:rPr sz="1350" b="0">
                 <a:solidFill>
                   <a:srgbClr val="000000"/>
                 </a:solidFill>
@@ -7173,23 +7191,24 @@
         </p:nvSpPr>
         <p:spPr>
           <a:xfrm xmlns:a="http://schemas.openxmlformats.org/drawingml/2006/main">
-            <a:off x="1200150" y="4772025"/>
-            <a:ext cx="209550" cy="266700"/>
-          </a:xfrm>
-          <a:prstGeom xmlns:a="http://schemas.openxmlformats.org/drawingml/2006/main" prst="rect">
-            <a:avLst/>
-          </a:prstGeom>
-          <a:noFill xmlns:a="http://schemas.openxmlformats.org/drawingml/2006/main"/>
-          <a:ln xmlns:a="http://schemas.openxmlformats.org/drawingml/2006/main" w="0">
-            <a:noFill/>
-            <a:prstDash val="solid"/>
-          </a:ln>
-        </p:spPr>
-        <p:txBody>
-          <a:bodyPr xmlns:a="http://schemas.openxmlformats.org/drawingml/2006/main"/>
-          <a:lstStyle xmlns:a="http://schemas.openxmlformats.org/drawingml/2006/main"/>
-          <a:p xmlns:a="http://schemas.openxmlformats.org/drawingml/2006/main">
-            <a:pPr algn="l">
+            <a:off x="1200150" y="4705350"/>
+            <a:ext cx="209550" cy="228600"/>
+          </a:xfrm>
+          <a:prstGeom xmlns:a="http://schemas.openxmlformats.org/drawingml/2006/main" prst="rect">
+            <a:avLst/>
+          </a:prstGeom>
+          <a:noFill xmlns:a="http://schemas.openxmlformats.org/drawingml/2006/main"/>
+          <a:ln xmlns:a="http://schemas.openxmlformats.org/drawingml/2006/main" w="0">
+            <a:noFill/>
+            <a:prstDash val="solid"/>
+          </a:ln>
+        </p:spPr>
+        <p:txBody>
+          <a:bodyPr xmlns:a="http://schemas.openxmlformats.org/drawingml/2006/main"/>
+          <a:lstStyle xmlns:a="http://schemas.openxmlformats.org/drawingml/2006/main"/>
+          <a:p xmlns:a="http://schemas.openxmlformats.org/drawingml/2006/main">
+            <a:pPr algn="l">
+              <a:buNone/>
               <a:defRPr sz="1575" b="1">
                 <a:solidFill>
                   <a:srgbClr val="3D8DFF"/>
@@ -7223,31 +7242,35 @@
         </p:nvSpPr>
         <p:spPr>
           <a:xfrm xmlns:a="http://schemas.openxmlformats.org/drawingml/2006/main">
-            <a:off x="1524000" y="4772025"/>
-            <a:ext cx="3105150" cy="323850"/>
-          </a:xfrm>
-          <a:prstGeom xmlns:a="http://schemas.openxmlformats.org/drawingml/2006/main" prst="rect">
-            <a:avLst/>
-          </a:prstGeom>
-          <a:noFill xmlns:a="http://schemas.openxmlformats.org/drawingml/2006/main"/>
-          <a:ln xmlns:a="http://schemas.openxmlformats.org/drawingml/2006/main" w="0">
-            <a:noFill/>
-            <a:prstDash val="solid"/>
-          </a:ln>
-        </p:spPr>
-        <p:txBody>
-          <a:bodyPr xmlns:a="http://schemas.openxmlformats.org/drawingml/2006/main"/>
-          <a:lstStyle xmlns:a="http://schemas.openxmlformats.org/drawingml/2006/main"/>
-          <a:p xmlns:a="http://schemas.openxmlformats.org/drawingml/2006/main">
-            <a:pPr algn="l">
-              <a:defRPr sz="1575" b="0">
-                <a:solidFill>
-                  <a:srgbClr val="000000"/>
-                </a:solidFill>
-              </a:defRPr>
-            </a:pPr>
-            <a:r>
-              <a:rPr sz="1575" b="0">
+            <a:off x="1524000" y="4705350"/>
+            <a:ext cx="3105150" cy="266700"/>
+          </a:xfrm>
+          <a:prstGeom xmlns:a="http://schemas.openxmlformats.org/drawingml/2006/main" prst="rect">
+            <a:avLst/>
+          </a:prstGeom>
+          <a:noFill xmlns:a="http://schemas.openxmlformats.org/drawingml/2006/main"/>
+          <a:ln xmlns:a="http://schemas.openxmlformats.org/drawingml/2006/main" w="0">
+            <a:noFill/>
+            <a:prstDash val="solid"/>
+          </a:ln>
+        </p:spPr>
+        <p:txBody>
+          <a:bodyPr xmlns:a="http://schemas.openxmlformats.org/drawingml/2006/main"/>
+          <a:lstStyle xmlns:a="http://schemas.openxmlformats.org/drawingml/2006/main"/>
+          <a:p xmlns:a="http://schemas.openxmlformats.org/drawingml/2006/main">
+            <a:pPr algn="l">
+              <a:lnSpc>
+                <a:spcPct val="106000"/>
+              </a:lnSpc>
+              <a:buNone/>
+              <a:defRPr sz="1350" b="0">
+                <a:solidFill>
+                  <a:srgbClr val="000000"/>
+                </a:solidFill>
+              </a:defRPr>
+            </a:pPr>
+            <a:r>
+              <a:rPr sz="1350" b="0">
                 <a:solidFill>
                   <a:srgbClr val="000000"/>
                 </a:solidFill>
@@ -7323,6 +7346,7 @@
           <a:lstStyle xmlns:a="http://schemas.openxmlformats.org/drawingml/2006/main"/>
           <a:p xmlns:a="http://schemas.openxmlformats.org/drawingml/2006/main">
             <a:pPr algn="l">
+              <a:buNone/>
               <a:defRPr sz="2250" b="1">
                 <a:solidFill>
                   <a:srgbClr val="000000"/>
@@ -7356,23 +7380,24 @@
         </p:nvSpPr>
         <p:spPr>
           <a:xfrm xmlns:a="http://schemas.openxmlformats.org/drawingml/2006/main">
-            <a:off x="6610350" y="3810000"/>
-            <a:ext cx="209550" cy="266700"/>
-          </a:xfrm>
-          <a:prstGeom xmlns:a="http://schemas.openxmlformats.org/drawingml/2006/main" prst="rect">
-            <a:avLst/>
-          </a:prstGeom>
-          <a:noFill xmlns:a="http://schemas.openxmlformats.org/drawingml/2006/main"/>
-          <a:ln xmlns:a="http://schemas.openxmlformats.org/drawingml/2006/main" w="0">
-            <a:noFill/>
-            <a:prstDash val="solid"/>
-          </a:ln>
-        </p:spPr>
-        <p:txBody>
-          <a:bodyPr xmlns:a="http://schemas.openxmlformats.org/drawingml/2006/main"/>
-          <a:lstStyle xmlns:a="http://schemas.openxmlformats.org/drawingml/2006/main"/>
-          <a:p xmlns:a="http://schemas.openxmlformats.org/drawingml/2006/main">
-            <a:pPr algn="l">
+            <a:off x="6610350" y="3733800"/>
+            <a:ext cx="209550" cy="219075"/>
+          </a:xfrm>
+          <a:prstGeom xmlns:a="http://schemas.openxmlformats.org/drawingml/2006/main" prst="rect">
+            <a:avLst/>
+          </a:prstGeom>
+          <a:noFill xmlns:a="http://schemas.openxmlformats.org/drawingml/2006/main"/>
+          <a:ln xmlns:a="http://schemas.openxmlformats.org/drawingml/2006/main" w="0">
+            <a:noFill/>
+            <a:prstDash val="solid"/>
+          </a:ln>
+        </p:spPr>
+        <p:txBody>
+          <a:bodyPr xmlns:a="http://schemas.openxmlformats.org/drawingml/2006/main"/>
+          <a:lstStyle xmlns:a="http://schemas.openxmlformats.org/drawingml/2006/main"/>
+          <a:p xmlns:a="http://schemas.openxmlformats.org/drawingml/2006/main">
+            <a:pPr algn="l">
+              <a:buNone/>
               <a:defRPr sz="1425" b="1">
                 <a:solidFill>
                   <a:srgbClr val="3D8DFF"/>
@@ -7406,31 +7431,35 @@
         </p:nvSpPr>
         <p:spPr>
           <a:xfrm xmlns:a="http://schemas.openxmlformats.org/drawingml/2006/main">
-            <a:off x="6934200" y="3810000"/>
-            <a:ext cx="3105150" cy="323850"/>
-          </a:xfrm>
-          <a:prstGeom xmlns:a="http://schemas.openxmlformats.org/drawingml/2006/main" prst="rect">
-            <a:avLst/>
-          </a:prstGeom>
-          <a:noFill xmlns:a="http://schemas.openxmlformats.org/drawingml/2006/main"/>
-          <a:ln xmlns:a="http://schemas.openxmlformats.org/drawingml/2006/main" w="0">
-            <a:noFill/>
-            <a:prstDash val="solid"/>
-          </a:ln>
-        </p:spPr>
-        <p:txBody>
-          <a:bodyPr xmlns:a="http://schemas.openxmlformats.org/drawingml/2006/main"/>
-          <a:lstStyle xmlns:a="http://schemas.openxmlformats.org/drawingml/2006/main"/>
-          <a:p xmlns:a="http://schemas.openxmlformats.org/drawingml/2006/main">
-            <a:pPr algn="l">
-              <a:defRPr sz="1425" b="0">
-                <a:solidFill>
-                  <a:srgbClr val="000000"/>
-                </a:solidFill>
-              </a:defRPr>
-            </a:pPr>
-            <a:r>
-              <a:rPr sz="1425" b="0">
+            <a:off x="6934200" y="3733800"/>
+            <a:ext cx="3105150" cy="238125"/>
+          </a:xfrm>
+          <a:prstGeom xmlns:a="http://schemas.openxmlformats.org/drawingml/2006/main" prst="rect">
+            <a:avLst/>
+          </a:prstGeom>
+          <a:noFill xmlns:a="http://schemas.openxmlformats.org/drawingml/2006/main"/>
+          <a:ln xmlns:a="http://schemas.openxmlformats.org/drawingml/2006/main" w="0">
+            <a:noFill/>
+            <a:prstDash val="solid"/>
+          </a:ln>
+        </p:spPr>
+        <p:txBody>
+          <a:bodyPr xmlns:a="http://schemas.openxmlformats.org/drawingml/2006/main"/>
+          <a:lstStyle xmlns:a="http://schemas.openxmlformats.org/drawingml/2006/main"/>
+          <a:p xmlns:a="http://schemas.openxmlformats.org/drawingml/2006/main">
+            <a:pPr algn="l">
+              <a:lnSpc>
+                <a:spcPct val="106000"/>
+              </a:lnSpc>
+              <a:buNone/>
+              <a:defRPr sz="1275" b="0">
+                <a:solidFill>
+                  <a:srgbClr val="000000"/>
+                </a:solidFill>
+              </a:defRPr>
+            </a:pPr>
+            <a:r>
+              <a:rPr sz="1275" b="0">
                 <a:solidFill>
                   <a:srgbClr val="000000"/>
                 </a:solidFill>
@@ -7456,23 +7485,24 @@
         </p:nvSpPr>
         <p:spPr>
           <a:xfrm xmlns:a="http://schemas.openxmlformats.org/drawingml/2006/main">
-            <a:off x="6610350" y="4076700"/>
-            <a:ext cx="209550" cy="266700"/>
-          </a:xfrm>
-          <a:prstGeom xmlns:a="http://schemas.openxmlformats.org/drawingml/2006/main" prst="rect">
-            <a:avLst/>
-          </a:prstGeom>
-          <a:noFill xmlns:a="http://schemas.openxmlformats.org/drawingml/2006/main"/>
-          <a:ln xmlns:a="http://schemas.openxmlformats.org/drawingml/2006/main" w="0">
-            <a:noFill/>
-            <a:prstDash val="solid"/>
-          </a:ln>
-        </p:spPr>
-        <p:txBody>
-          <a:bodyPr xmlns:a="http://schemas.openxmlformats.org/drawingml/2006/main"/>
-          <a:lstStyle xmlns:a="http://schemas.openxmlformats.org/drawingml/2006/main"/>
-          <a:p xmlns:a="http://schemas.openxmlformats.org/drawingml/2006/main">
-            <a:pPr algn="l">
+            <a:off x="6610350" y="3990975"/>
+            <a:ext cx="209550" cy="219075"/>
+          </a:xfrm>
+          <a:prstGeom xmlns:a="http://schemas.openxmlformats.org/drawingml/2006/main" prst="rect">
+            <a:avLst/>
+          </a:prstGeom>
+          <a:noFill xmlns:a="http://schemas.openxmlformats.org/drawingml/2006/main"/>
+          <a:ln xmlns:a="http://schemas.openxmlformats.org/drawingml/2006/main" w="0">
+            <a:noFill/>
+            <a:prstDash val="solid"/>
+          </a:ln>
+        </p:spPr>
+        <p:txBody>
+          <a:bodyPr xmlns:a="http://schemas.openxmlformats.org/drawingml/2006/main"/>
+          <a:lstStyle xmlns:a="http://schemas.openxmlformats.org/drawingml/2006/main"/>
+          <a:p xmlns:a="http://schemas.openxmlformats.org/drawingml/2006/main">
+            <a:pPr algn="l">
+              <a:buNone/>
               <a:defRPr sz="1425" b="1">
                 <a:solidFill>
                   <a:srgbClr val="3D8DFF"/>
@@ -7506,31 +7536,35 @@
         </p:nvSpPr>
         <p:spPr>
           <a:xfrm xmlns:a="http://schemas.openxmlformats.org/drawingml/2006/main">
-            <a:off x="6934200" y="4076700"/>
-            <a:ext cx="3105150" cy="323850"/>
-          </a:xfrm>
-          <a:prstGeom xmlns:a="http://schemas.openxmlformats.org/drawingml/2006/main" prst="rect">
-            <a:avLst/>
-          </a:prstGeom>
-          <a:noFill xmlns:a="http://schemas.openxmlformats.org/drawingml/2006/main"/>
-          <a:ln xmlns:a="http://schemas.openxmlformats.org/drawingml/2006/main" w="0">
-            <a:noFill/>
-            <a:prstDash val="solid"/>
-          </a:ln>
-        </p:spPr>
-        <p:txBody>
-          <a:bodyPr xmlns:a="http://schemas.openxmlformats.org/drawingml/2006/main"/>
-          <a:lstStyle xmlns:a="http://schemas.openxmlformats.org/drawingml/2006/main"/>
-          <a:p xmlns:a="http://schemas.openxmlformats.org/drawingml/2006/main">
-            <a:pPr algn="l">
-              <a:defRPr sz="1425" b="0">
-                <a:solidFill>
-                  <a:srgbClr val="000000"/>
-                </a:solidFill>
-              </a:defRPr>
-            </a:pPr>
-            <a:r>
-              <a:rPr sz="1425" b="0">
+            <a:off x="6934200" y="3990975"/>
+            <a:ext cx="3105150" cy="238125"/>
+          </a:xfrm>
+          <a:prstGeom xmlns:a="http://schemas.openxmlformats.org/drawingml/2006/main" prst="rect">
+            <a:avLst/>
+          </a:prstGeom>
+          <a:noFill xmlns:a="http://schemas.openxmlformats.org/drawingml/2006/main"/>
+          <a:ln xmlns:a="http://schemas.openxmlformats.org/drawingml/2006/main" w="0">
+            <a:noFill/>
+            <a:prstDash val="solid"/>
+          </a:ln>
+        </p:spPr>
+        <p:txBody>
+          <a:bodyPr xmlns:a="http://schemas.openxmlformats.org/drawingml/2006/main"/>
+          <a:lstStyle xmlns:a="http://schemas.openxmlformats.org/drawingml/2006/main"/>
+          <a:p xmlns:a="http://schemas.openxmlformats.org/drawingml/2006/main">
+            <a:pPr algn="l">
+              <a:lnSpc>
+                <a:spcPct val="106000"/>
+              </a:lnSpc>
+              <a:buNone/>
+              <a:defRPr sz="1275" b="0">
+                <a:solidFill>
+                  <a:srgbClr val="000000"/>
+                </a:solidFill>
+              </a:defRPr>
+            </a:pPr>
+            <a:r>
+              <a:rPr sz="1275" b="0">
                 <a:solidFill>
                   <a:srgbClr val="000000"/>
                 </a:solidFill>
@@ -7556,23 +7590,24 @@
         </p:nvSpPr>
         <p:spPr>
           <a:xfrm xmlns:a="http://schemas.openxmlformats.org/drawingml/2006/main">
-            <a:off x="6610350" y="4343400"/>
-            <a:ext cx="209550" cy="266700"/>
-          </a:xfrm>
-          <a:prstGeom xmlns:a="http://schemas.openxmlformats.org/drawingml/2006/main" prst="rect">
-            <a:avLst/>
-          </a:prstGeom>
-          <a:noFill xmlns:a="http://schemas.openxmlformats.org/drawingml/2006/main"/>
-          <a:ln xmlns:a="http://schemas.openxmlformats.org/drawingml/2006/main" w="0">
-            <a:noFill/>
-            <a:prstDash val="solid"/>
-          </a:ln>
-        </p:spPr>
-        <p:txBody>
-          <a:bodyPr xmlns:a="http://schemas.openxmlformats.org/drawingml/2006/main"/>
-          <a:lstStyle xmlns:a="http://schemas.openxmlformats.org/drawingml/2006/main"/>
-          <a:p xmlns:a="http://schemas.openxmlformats.org/drawingml/2006/main">
-            <a:pPr algn="l">
+            <a:off x="6610350" y="4248150"/>
+            <a:ext cx="209550" cy="219075"/>
+          </a:xfrm>
+          <a:prstGeom xmlns:a="http://schemas.openxmlformats.org/drawingml/2006/main" prst="rect">
+            <a:avLst/>
+          </a:prstGeom>
+          <a:noFill xmlns:a="http://schemas.openxmlformats.org/drawingml/2006/main"/>
+          <a:ln xmlns:a="http://schemas.openxmlformats.org/drawingml/2006/main" w="0">
+            <a:noFill/>
+            <a:prstDash val="solid"/>
+          </a:ln>
+        </p:spPr>
+        <p:txBody>
+          <a:bodyPr xmlns:a="http://schemas.openxmlformats.org/drawingml/2006/main"/>
+          <a:lstStyle xmlns:a="http://schemas.openxmlformats.org/drawingml/2006/main"/>
+          <a:p xmlns:a="http://schemas.openxmlformats.org/drawingml/2006/main">
+            <a:pPr algn="l">
+              <a:buNone/>
               <a:defRPr sz="1425" b="1">
                 <a:solidFill>
                   <a:srgbClr val="3D8DFF"/>
@@ -7606,31 +7641,35 @@
         </p:nvSpPr>
         <p:spPr>
           <a:xfrm xmlns:a="http://schemas.openxmlformats.org/drawingml/2006/main">
-            <a:off x="6934200" y="4343400"/>
-            <a:ext cx="3105150" cy="323850"/>
-          </a:xfrm>
-          <a:prstGeom xmlns:a="http://schemas.openxmlformats.org/drawingml/2006/main" prst="rect">
-            <a:avLst/>
-          </a:prstGeom>
-          <a:noFill xmlns:a="http://schemas.openxmlformats.org/drawingml/2006/main"/>
-          <a:ln xmlns:a="http://schemas.openxmlformats.org/drawingml/2006/main" w="0">
-            <a:noFill/>
-            <a:prstDash val="solid"/>
-          </a:ln>
-        </p:spPr>
-        <p:txBody>
-          <a:bodyPr xmlns:a="http://schemas.openxmlformats.org/drawingml/2006/main"/>
-          <a:lstStyle xmlns:a="http://schemas.openxmlformats.org/drawingml/2006/main"/>
-          <a:p xmlns:a="http://schemas.openxmlformats.org/drawingml/2006/main">
-            <a:pPr algn="l">
-              <a:defRPr sz="1425" b="0">
-                <a:solidFill>
-                  <a:srgbClr val="000000"/>
-                </a:solidFill>
-              </a:defRPr>
-            </a:pPr>
-            <a:r>
-              <a:rPr sz="1425" b="0">
+            <a:off x="6934200" y="4248150"/>
+            <a:ext cx="3105150" cy="238125"/>
+          </a:xfrm>
+          <a:prstGeom xmlns:a="http://schemas.openxmlformats.org/drawingml/2006/main" prst="rect">
+            <a:avLst/>
+          </a:prstGeom>
+          <a:noFill xmlns:a="http://schemas.openxmlformats.org/drawingml/2006/main"/>
+          <a:ln xmlns:a="http://schemas.openxmlformats.org/drawingml/2006/main" w="0">
+            <a:noFill/>
+            <a:prstDash val="solid"/>
+          </a:ln>
+        </p:spPr>
+        <p:txBody>
+          <a:bodyPr xmlns:a="http://schemas.openxmlformats.org/drawingml/2006/main"/>
+          <a:lstStyle xmlns:a="http://schemas.openxmlformats.org/drawingml/2006/main"/>
+          <a:p xmlns:a="http://schemas.openxmlformats.org/drawingml/2006/main">
+            <a:pPr algn="l">
+              <a:lnSpc>
+                <a:spcPct val="106000"/>
+              </a:lnSpc>
+              <a:buNone/>
+              <a:defRPr sz="1275" b="0">
+                <a:solidFill>
+                  <a:srgbClr val="000000"/>
+                </a:solidFill>
+              </a:defRPr>
+            </a:pPr>
+            <a:r>
+              <a:rPr sz="1275" b="0">
                 <a:solidFill>
                   <a:srgbClr val="000000"/>
                 </a:solidFill>
@@ -7656,23 +7695,24 @@
         </p:nvSpPr>
         <p:spPr>
           <a:xfrm xmlns:a="http://schemas.openxmlformats.org/drawingml/2006/main">
-            <a:off x="6610350" y="4610100"/>
-            <a:ext cx="209550" cy="266700"/>
-          </a:xfrm>
-          <a:prstGeom xmlns:a="http://schemas.openxmlformats.org/drawingml/2006/main" prst="rect">
-            <a:avLst/>
-          </a:prstGeom>
-          <a:noFill xmlns:a="http://schemas.openxmlformats.org/drawingml/2006/main"/>
-          <a:ln xmlns:a="http://schemas.openxmlformats.org/drawingml/2006/main" w="0">
-            <a:noFill/>
-            <a:prstDash val="solid"/>
-          </a:ln>
-        </p:spPr>
-        <p:txBody>
-          <a:bodyPr xmlns:a="http://schemas.openxmlformats.org/drawingml/2006/main"/>
-          <a:lstStyle xmlns:a="http://schemas.openxmlformats.org/drawingml/2006/main"/>
-          <a:p xmlns:a="http://schemas.openxmlformats.org/drawingml/2006/main">
-            <a:pPr algn="l">
+            <a:off x="6610350" y="4505325"/>
+            <a:ext cx="209550" cy="219075"/>
+          </a:xfrm>
+          <a:prstGeom xmlns:a="http://schemas.openxmlformats.org/drawingml/2006/main" prst="rect">
+            <a:avLst/>
+          </a:prstGeom>
+          <a:noFill xmlns:a="http://schemas.openxmlformats.org/drawingml/2006/main"/>
+          <a:ln xmlns:a="http://schemas.openxmlformats.org/drawingml/2006/main" w="0">
+            <a:noFill/>
+            <a:prstDash val="solid"/>
+          </a:ln>
+        </p:spPr>
+        <p:txBody>
+          <a:bodyPr xmlns:a="http://schemas.openxmlformats.org/drawingml/2006/main"/>
+          <a:lstStyle xmlns:a="http://schemas.openxmlformats.org/drawingml/2006/main"/>
+          <a:p xmlns:a="http://schemas.openxmlformats.org/drawingml/2006/main">
+            <a:pPr algn="l">
+              <a:buNone/>
               <a:defRPr sz="1425" b="1">
                 <a:solidFill>
                   <a:srgbClr val="3D8DFF"/>
@@ -7706,31 +7746,35 @@
         </p:nvSpPr>
         <p:spPr>
           <a:xfrm xmlns:a="http://schemas.openxmlformats.org/drawingml/2006/main">
-            <a:off x="6934200" y="4610100"/>
-            <a:ext cx="3105150" cy="323850"/>
-          </a:xfrm>
-          <a:prstGeom xmlns:a="http://schemas.openxmlformats.org/drawingml/2006/main" prst="rect">
-            <a:avLst/>
-          </a:prstGeom>
-          <a:noFill xmlns:a="http://schemas.openxmlformats.org/drawingml/2006/main"/>
-          <a:ln xmlns:a="http://schemas.openxmlformats.org/drawingml/2006/main" w="0">
-            <a:noFill/>
-            <a:prstDash val="solid"/>
-          </a:ln>
-        </p:spPr>
-        <p:txBody>
-          <a:bodyPr xmlns:a="http://schemas.openxmlformats.org/drawingml/2006/main"/>
-          <a:lstStyle xmlns:a="http://schemas.openxmlformats.org/drawingml/2006/main"/>
-          <a:p xmlns:a="http://schemas.openxmlformats.org/drawingml/2006/main">
-            <a:pPr algn="l">
-              <a:defRPr sz="1425" b="0">
-                <a:solidFill>
-                  <a:srgbClr val="000000"/>
-                </a:solidFill>
-              </a:defRPr>
-            </a:pPr>
-            <a:r>
-              <a:rPr sz="1425" b="0">
+            <a:off x="6934200" y="4505325"/>
+            <a:ext cx="3105150" cy="238125"/>
+          </a:xfrm>
+          <a:prstGeom xmlns:a="http://schemas.openxmlformats.org/drawingml/2006/main" prst="rect">
+            <a:avLst/>
+          </a:prstGeom>
+          <a:noFill xmlns:a="http://schemas.openxmlformats.org/drawingml/2006/main"/>
+          <a:ln xmlns:a="http://schemas.openxmlformats.org/drawingml/2006/main" w="0">
+            <a:noFill/>
+            <a:prstDash val="solid"/>
+          </a:ln>
+        </p:spPr>
+        <p:txBody>
+          <a:bodyPr xmlns:a="http://schemas.openxmlformats.org/drawingml/2006/main"/>
+          <a:lstStyle xmlns:a="http://schemas.openxmlformats.org/drawingml/2006/main"/>
+          <a:p xmlns:a="http://schemas.openxmlformats.org/drawingml/2006/main">
+            <a:pPr algn="l">
+              <a:lnSpc>
+                <a:spcPct val="106000"/>
+              </a:lnSpc>
+              <a:buNone/>
+              <a:defRPr sz="1275" b="0">
+                <a:solidFill>
+                  <a:srgbClr val="000000"/>
+                </a:solidFill>
+              </a:defRPr>
+            </a:pPr>
+            <a:r>
+              <a:rPr sz="1275" b="0">
                 <a:solidFill>
                   <a:srgbClr val="000000"/>
                 </a:solidFill>
@@ -7756,23 +7800,24 @@
         </p:nvSpPr>
         <p:spPr>
           <a:xfrm xmlns:a="http://schemas.openxmlformats.org/drawingml/2006/main">
-            <a:off x="6610350" y="4876800"/>
-            <a:ext cx="209550" cy="266700"/>
-          </a:xfrm>
-          <a:prstGeom xmlns:a="http://schemas.openxmlformats.org/drawingml/2006/main" prst="rect">
-            <a:avLst/>
-          </a:prstGeom>
-          <a:noFill xmlns:a="http://schemas.openxmlformats.org/drawingml/2006/main"/>
-          <a:ln xmlns:a="http://schemas.openxmlformats.org/drawingml/2006/main" w="0">
-            <a:noFill/>
-            <a:prstDash val="solid"/>
-          </a:ln>
-        </p:spPr>
-        <p:txBody>
-          <a:bodyPr xmlns:a="http://schemas.openxmlformats.org/drawingml/2006/main"/>
-          <a:lstStyle xmlns:a="http://schemas.openxmlformats.org/drawingml/2006/main"/>
-          <a:p xmlns:a="http://schemas.openxmlformats.org/drawingml/2006/main">
-            <a:pPr algn="l">
+            <a:off x="6610350" y="4762500"/>
+            <a:ext cx="209550" cy="219075"/>
+          </a:xfrm>
+          <a:prstGeom xmlns:a="http://schemas.openxmlformats.org/drawingml/2006/main" prst="rect">
+            <a:avLst/>
+          </a:prstGeom>
+          <a:noFill xmlns:a="http://schemas.openxmlformats.org/drawingml/2006/main"/>
+          <a:ln xmlns:a="http://schemas.openxmlformats.org/drawingml/2006/main" w="0">
+            <a:noFill/>
+            <a:prstDash val="solid"/>
+          </a:ln>
+        </p:spPr>
+        <p:txBody>
+          <a:bodyPr xmlns:a="http://schemas.openxmlformats.org/drawingml/2006/main"/>
+          <a:lstStyle xmlns:a="http://schemas.openxmlformats.org/drawingml/2006/main"/>
+          <a:p xmlns:a="http://schemas.openxmlformats.org/drawingml/2006/main">
+            <a:pPr algn="l">
+              <a:buNone/>
               <a:defRPr sz="1425" b="1">
                 <a:solidFill>
                   <a:srgbClr val="3D8DFF"/>
@@ -7806,31 +7851,35 @@
         </p:nvSpPr>
         <p:spPr>
           <a:xfrm xmlns:a="http://schemas.openxmlformats.org/drawingml/2006/main">
-            <a:off x="6934200" y="4876800"/>
-            <a:ext cx="3105150" cy="323850"/>
-          </a:xfrm>
-          <a:prstGeom xmlns:a="http://schemas.openxmlformats.org/drawingml/2006/main" prst="rect">
-            <a:avLst/>
-          </a:prstGeom>
-          <a:noFill xmlns:a="http://schemas.openxmlformats.org/drawingml/2006/main"/>
-          <a:ln xmlns:a="http://schemas.openxmlformats.org/drawingml/2006/main" w="0">
-            <a:noFill/>
-            <a:prstDash val="solid"/>
-          </a:ln>
-        </p:spPr>
-        <p:txBody>
-          <a:bodyPr xmlns:a="http://schemas.openxmlformats.org/drawingml/2006/main"/>
-          <a:lstStyle xmlns:a="http://schemas.openxmlformats.org/drawingml/2006/main"/>
-          <a:p xmlns:a="http://schemas.openxmlformats.org/drawingml/2006/main">
-            <a:pPr algn="l">
-              <a:defRPr sz="1425" b="0">
-                <a:solidFill>
-                  <a:srgbClr val="000000"/>
-                </a:solidFill>
-              </a:defRPr>
-            </a:pPr>
-            <a:r>
-              <a:rPr sz="1425" b="0">
+            <a:off x="6934200" y="4762500"/>
+            <a:ext cx="3105150" cy="238125"/>
+          </a:xfrm>
+          <a:prstGeom xmlns:a="http://schemas.openxmlformats.org/drawingml/2006/main" prst="rect">
+            <a:avLst/>
+          </a:prstGeom>
+          <a:noFill xmlns:a="http://schemas.openxmlformats.org/drawingml/2006/main"/>
+          <a:ln xmlns:a="http://schemas.openxmlformats.org/drawingml/2006/main" w="0">
+            <a:noFill/>
+            <a:prstDash val="solid"/>
+          </a:ln>
+        </p:spPr>
+        <p:txBody>
+          <a:bodyPr xmlns:a="http://schemas.openxmlformats.org/drawingml/2006/main"/>
+          <a:lstStyle xmlns:a="http://schemas.openxmlformats.org/drawingml/2006/main"/>
+          <a:p xmlns:a="http://schemas.openxmlformats.org/drawingml/2006/main">
+            <a:pPr algn="l">
+              <a:lnSpc>
+                <a:spcPct val="106000"/>
+              </a:lnSpc>
+              <a:buNone/>
+              <a:defRPr sz="1275" b="0">
+                <a:solidFill>
+                  <a:srgbClr val="000000"/>
+                </a:solidFill>
+              </a:defRPr>
+            </a:pPr>
+            <a:r>
+              <a:rPr sz="1275" b="0">
                 <a:solidFill>
                   <a:srgbClr val="000000"/>
                 </a:solidFill>
@@ -7856,23 +7905,24 @@
         </p:nvSpPr>
         <p:spPr>
           <a:xfrm xmlns:a="http://schemas.openxmlformats.org/drawingml/2006/main">
-            <a:off x="6610350" y="5143500"/>
-            <a:ext cx="209550" cy="266700"/>
-          </a:xfrm>
-          <a:prstGeom xmlns:a="http://schemas.openxmlformats.org/drawingml/2006/main" prst="rect">
-            <a:avLst/>
-          </a:prstGeom>
-          <a:noFill xmlns:a="http://schemas.openxmlformats.org/drawingml/2006/main"/>
-          <a:ln xmlns:a="http://schemas.openxmlformats.org/drawingml/2006/main" w="0">
-            <a:noFill/>
-            <a:prstDash val="solid"/>
-          </a:ln>
-        </p:spPr>
-        <p:txBody>
-          <a:bodyPr xmlns:a="http://schemas.openxmlformats.org/drawingml/2006/main"/>
-          <a:lstStyle xmlns:a="http://schemas.openxmlformats.org/drawingml/2006/main"/>
-          <a:p xmlns:a="http://schemas.openxmlformats.org/drawingml/2006/main">
-            <a:pPr algn="l">
+            <a:off x="6610350" y="5019675"/>
+            <a:ext cx="209550" cy="219075"/>
+          </a:xfrm>
+          <a:prstGeom xmlns:a="http://schemas.openxmlformats.org/drawingml/2006/main" prst="rect">
+            <a:avLst/>
+          </a:prstGeom>
+          <a:noFill xmlns:a="http://schemas.openxmlformats.org/drawingml/2006/main"/>
+          <a:ln xmlns:a="http://schemas.openxmlformats.org/drawingml/2006/main" w="0">
+            <a:noFill/>
+            <a:prstDash val="solid"/>
+          </a:ln>
+        </p:spPr>
+        <p:txBody>
+          <a:bodyPr xmlns:a="http://schemas.openxmlformats.org/drawingml/2006/main"/>
+          <a:lstStyle xmlns:a="http://schemas.openxmlformats.org/drawingml/2006/main"/>
+          <a:p xmlns:a="http://schemas.openxmlformats.org/drawingml/2006/main">
+            <a:pPr algn="l">
+              <a:buNone/>
               <a:defRPr sz="1425" b="1">
                 <a:solidFill>
                   <a:srgbClr val="3D8DFF"/>
@@ -7906,36 +7956,40 @@
         </p:nvSpPr>
         <p:spPr>
           <a:xfrm xmlns:a="http://schemas.openxmlformats.org/drawingml/2006/main">
-            <a:off x="6934200" y="5143500"/>
-            <a:ext cx="3105150" cy="323850"/>
-          </a:xfrm>
-          <a:prstGeom xmlns:a="http://schemas.openxmlformats.org/drawingml/2006/main" prst="rect">
-            <a:avLst/>
-          </a:prstGeom>
-          <a:noFill xmlns:a="http://schemas.openxmlformats.org/drawingml/2006/main"/>
-          <a:ln xmlns:a="http://schemas.openxmlformats.org/drawingml/2006/main" w="0">
-            <a:noFill/>
-            <a:prstDash val="solid"/>
-          </a:ln>
-        </p:spPr>
-        <p:txBody>
-          <a:bodyPr xmlns:a="http://schemas.openxmlformats.org/drawingml/2006/main"/>
-          <a:lstStyle xmlns:a="http://schemas.openxmlformats.org/drawingml/2006/main"/>
-          <a:p xmlns:a="http://schemas.openxmlformats.org/drawingml/2006/main">
-            <a:pPr algn="l">
-              <a:defRPr sz="1425" b="0">
-                <a:solidFill>
-                  <a:srgbClr val="000000"/>
-                </a:solidFill>
-              </a:defRPr>
-            </a:pPr>
-            <a:r>
-              <a:rPr sz="1425" b="0">
-                <a:solidFill>
-                  <a:srgbClr val="000000"/>
-                </a:solidFill>
-              </a:rPr>
-              <a:t>routing and spend</a:t>
+            <a:off x="6934200" y="5019675"/>
+            <a:ext cx="3105150" cy="238125"/>
+          </a:xfrm>
+          <a:prstGeom xmlns:a="http://schemas.openxmlformats.org/drawingml/2006/main" prst="rect">
+            <a:avLst/>
+          </a:prstGeom>
+          <a:noFill xmlns:a="http://schemas.openxmlformats.org/drawingml/2006/main"/>
+          <a:ln xmlns:a="http://schemas.openxmlformats.org/drawingml/2006/main" w="0">
+            <a:noFill/>
+            <a:prstDash val="solid"/>
+          </a:ln>
+        </p:spPr>
+        <p:txBody>
+          <a:bodyPr xmlns:a="http://schemas.openxmlformats.org/drawingml/2006/main"/>
+          <a:lstStyle xmlns:a="http://schemas.openxmlformats.org/drawingml/2006/main"/>
+          <a:p xmlns:a="http://schemas.openxmlformats.org/drawingml/2006/main">
+            <a:pPr algn="l">
+              <a:lnSpc>
+                <a:spcPct val="106000"/>
+              </a:lnSpc>
+              <a:buNone/>
+              <a:defRPr sz="1275" b="0">
+                <a:solidFill>
+                  <a:srgbClr val="000000"/>
+                </a:solidFill>
+              </a:defRPr>
+            </a:pPr>
+            <a:r>
+              <a:rPr sz="1275" b="0">
+                <a:solidFill>
+                  <a:srgbClr val="000000"/>
+                </a:solidFill>
+              </a:rPr>
+              <a:t>AI Program + GRC app</a:t>
             </a:r>
           </a:p>
         </p:txBody>
@@ -7973,6 +8027,7 @@
           <a:lstStyle xmlns:a="http://schemas.openxmlformats.org/drawingml/2006/main"/>
           <a:p xmlns:a="http://schemas.openxmlformats.org/drawingml/2006/main">
             <a:pPr algn="r">
+              <a:buNone/>
               <a:defRPr sz="975" b="0">
                 <a:solidFill>
                   <a:srgbClr val="60646C"/>
@@ -8045,6 +8100,7 @@
           <a:lstStyle xmlns:a="http://schemas.openxmlformats.org/drawingml/2006/main"/>
           <a:p xmlns:a="http://schemas.openxmlformats.org/drawingml/2006/main">
             <a:pPr algn="l">
+              <a:buNone/>
               <a:defRPr sz="4200" b="1">
                 <a:solidFill>
                   <a:srgbClr val="000000"/>
@@ -8095,6 +8151,7 @@
           <a:lstStyle xmlns:a="http://schemas.openxmlformats.org/drawingml/2006/main"/>
           <a:p xmlns:a="http://schemas.openxmlformats.org/drawingml/2006/main">
             <a:pPr algn="l">
+              <a:buNone/>
               <a:defRPr sz="2325" b="0">
                 <a:solidFill>
                   <a:srgbClr val="60646C"/>
@@ -8176,6 +8233,7 @@
           <a:lstStyle xmlns:a="http://schemas.openxmlformats.org/drawingml/2006/main"/>
           <a:p xmlns:a="http://schemas.openxmlformats.org/drawingml/2006/main">
             <a:pPr algn="l">
+              <a:buNone/>
               <a:defRPr sz="1875" b="1">
                 <a:solidFill>
                   <a:srgbClr val="000000"/>
@@ -8226,6 +8284,7 @@
           <a:lstStyle xmlns:a="http://schemas.openxmlformats.org/drawingml/2006/main"/>
           <a:p xmlns:a="http://schemas.openxmlformats.org/drawingml/2006/main">
             <a:pPr algn="l">
+              <a:buNone/>
               <a:defRPr sz="1725" b="1">
                 <a:solidFill>
                   <a:srgbClr val="3D8DFF"/>
@@ -8276,6 +8335,7 @@
           <a:lstStyle xmlns:a="http://schemas.openxmlformats.org/drawingml/2006/main"/>
           <a:p xmlns:a="http://schemas.openxmlformats.org/drawingml/2006/main">
             <a:pPr algn="l">
+              <a:buNone/>
               <a:defRPr sz="1725" b="0">
                 <a:solidFill>
                   <a:srgbClr val="000000"/>
@@ -8326,6 +8386,7 @@
           <a:lstStyle xmlns:a="http://schemas.openxmlformats.org/drawingml/2006/main"/>
           <a:p xmlns:a="http://schemas.openxmlformats.org/drawingml/2006/main">
             <a:pPr algn="l">
+              <a:buNone/>
               <a:defRPr sz="1725" b="1">
                 <a:solidFill>
                   <a:srgbClr val="3D8DFF"/>
@@ -8376,6 +8437,7 @@
           <a:lstStyle xmlns:a="http://schemas.openxmlformats.org/drawingml/2006/main"/>
           <a:p xmlns:a="http://schemas.openxmlformats.org/drawingml/2006/main">
             <a:pPr algn="l">
+              <a:buNone/>
               <a:defRPr sz="1725" b="0">
                 <a:solidFill>
                   <a:srgbClr val="000000"/>
@@ -8426,6 +8488,7 @@
           <a:lstStyle xmlns:a="http://schemas.openxmlformats.org/drawingml/2006/main"/>
           <a:p xmlns:a="http://schemas.openxmlformats.org/drawingml/2006/main">
             <a:pPr algn="l">
+              <a:buNone/>
               <a:defRPr sz="1725" b="1">
                 <a:solidFill>
                   <a:srgbClr val="3D8DFF"/>
@@ -8476,6 +8539,7 @@
           <a:lstStyle xmlns:a="http://schemas.openxmlformats.org/drawingml/2006/main"/>
           <a:p xmlns:a="http://schemas.openxmlformats.org/drawingml/2006/main">
             <a:pPr algn="l">
+              <a:buNone/>
               <a:defRPr sz="1725" b="0">
                 <a:solidFill>
                   <a:srgbClr val="000000"/>
@@ -8526,6 +8590,7 @@
           <a:lstStyle xmlns:a="http://schemas.openxmlformats.org/drawingml/2006/main"/>
           <a:p xmlns:a="http://schemas.openxmlformats.org/drawingml/2006/main">
             <a:pPr algn="l">
+              <a:buNone/>
               <a:defRPr sz="1725" b="1">
                 <a:solidFill>
                   <a:srgbClr val="3D8DFF"/>
@@ -8576,6 +8641,7 @@
           <a:lstStyle xmlns:a="http://schemas.openxmlformats.org/drawingml/2006/main"/>
           <a:p xmlns:a="http://schemas.openxmlformats.org/drawingml/2006/main">
             <a:pPr algn="l">
+              <a:buNone/>
               <a:defRPr sz="1725" b="0">
                 <a:solidFill>
                   <a:srgbClr val="000000"/>
@@ -8626,6 +8692,7 @@
           <a:lstStyle xmlns:a="http://schemas.openxmlformats.org/drawingml/2006/main"/>
           <a:p xmlns:a="http://schemas.openxmlformats.org/drawingml/2006/main">
             <a:pPr algn="r">
+              <a:buNone/>
               <a:defRPr sz="975" b="0">
                 <a:solidFill>
                   <a:srgbClr val="60646C"/>
@@ -8698,6 +8765,7 @@
           <a:lstStyle xmlns:a="http://schemas.openxmlformats.org/drawingml/2006/main"/>
           <a:p xmlns:a="http://schemas.openxmlformats.org/drawingml/2006/main">
             <a:pPr algn="l">
+              <a:buNone/>
               <a:defRPr sz="1125" b="1">
                 <a:solidFill>
                   <a:srgbClr val="60646C"/>
@@ -8748,6 +8816,7 @@
           <a:lstStyle xmlns:a="http://schemas.openxmlformats.org/drawingml/2006/main"/>
           <a:p xmlns:a="http://schemas.openxmlformats.org/drawingml/2006/main">
             <a:pPr algn="l">
+              <a:buNone/>
               <a:defRPr sz="3750" b="1">
                 <a:solidFill>
                   <a:srgbClr val="000000"/>
@@ -8864,6 +8933,7 @@
           <a:lstStyle xmlns:a="http://schemas.openxmlformats.org/drawingml/2006/main"/>
           <a:p xmlns:a="http://schemas.openxmlformats.org/drawingml/2006/main">
             <a:pPr algn="l">
+              <a:buNone/>
               <a:defRPr sz="2250" b="1">
                 <a:solidFill>
                   <a:srgbClr val="000000"/>
@@ -8914,6 +8984,7 @@
           <a:lstStyle xmlns:a="http://schemas.openxmlformats.org/drawingml/2006/main"/>
           <a:p xmlns:a="http://schemas.openxmlformats.org/drawingml/2006/main">
             <a:pPr algn="l">
+              <a:buNone/>
               <a:defRPr sz="1575" b="1">
                 <a:solidFill>
                   <a:srgbClr val="3D8DFF"/>
@@ -8964,6 +9035,7 @@
           <a:lstStyle xmlns:a="http://schemas.openxmlformats.org/drawingml/2006/main"/>
           <a:p xmlns:a="http://schemas.openxmlformats.org/drawingml/2006/main">
             <a:pPr algn="l">
+              <a:buNone/>
               <a:defRPr sz="1575" b="0">
                 <a:solidFill>
                   <a:srgbClr val="000000"/>
@@ -9014,6 +9086,7 @@
           <a:lstStyle xmlns:a="http://schemas.openxmlformats.org/drawingml/2006/main"/>
           <a:p xmlns:a="http://schemas.openxmlformats.org/drawingml/2006/main">
             <a:pPr algn="l">
+              <a:buNone/>
               <a:defRPr sz="1575" b="1">
                 <a:solidFill>
                   <a:srgbClr val="3D8DFF"/>
@@ -9064,6 +9137,7 @@
           <a:lstStyle xmlns:a="http://schemas.openxmlformats.org/drawingml/2006/main"/>
           <a:p xmlns:a="http://schemas.openxmlformats.org/drawingml/2006/main">
             <a:pPr algn="l">
+              <a:buNone/>
               <a:defRPr sz="1575" b="0">
                 <a:solidFill>
                   <a:srgbClr val="000000"/>
@@ -9114,6 +9188,7 @@
           <a:lstStyle xmlns:a="http://schemas.openxmlformats.org/drawingml/2006/main"/>
           <a:p xmlns:a="http://schemas.openxmlformats.org/drawingml/2006/main">
             <a:pPr algn="l">
+              <a:buNone/>
               <a:defRPr sz="1575" b="1">
                 <a:solidFill>
                   <a:srgbClr val="3D8DFF"/>
@@ -9164,6 +9239,7 @@
           <a:lstStyle xmlns:a="http://schemas.openxmlformats.org/drawingml/2006/main"/>
           <a:p xmlns:a="http://schemas.openxmlformats.org/drawingml/2006/main">
             <a:pPr algn="l">
+              <a:buNone/>
               <a:defRPr sz="1575" b="0">
                 <a:solidFill>
                   <a:srgbClr val="000000"/>
@@ -9214,6 +9290,7 @@
           <a:lstStyle xmlns:a="http://schemas.openxmlformats.org/drawingml/2006/main"/>
           <a:p xmlns:a="http://schemas.openxmlformats.org/drawingml/2006/main">
             <a:pPr algn="l">
+              <a:buNone/>
               <a:defRPr sz="2250" b="1">
                 <a:solidFill>
                   <a:srgbClr val="000000"/>
@@ -9264,6 +9341,7 @@
           <a:lstStyle xmlns:a="http://schemas.openxmlformats.org/drawingml/2006/main"/>
           <a:p xmlns:a="http://schemas.openxmlformats.org/drawingml/2006/main">
             <a:pPr algn="l">
+              <a:buNone/>
               <a:defRPr sz="1575" b="1">
                 <a:solidFill>
                   <a:srgbClr val="3D8DFF"/>
@@ -9314,6 +9392,7 @@
           <a:lstStyle xmlns:a="http://schemas.openxmlformats.org/drawingml/2006/main"/>
           <a:p xmlns:a="http://schemas.openxmlformats.org/drawingml/2006/main">
             <a:pPr algn="l">
+              <a:buNone/>
               <a:defRPr sz="1575" b="0">
                 <a:solidFill>
                   <a:srgbClr val="000000"/>
@@ -9364,6 +9443,7 @@
           <a:lstStyle xmlns:a="http://schemas.openxmlformats.org/drawingml/2006/main"/>
           <a:p xmlns:a="http://schemas.openxmlformats.org/drawingml/2006/main">
             <a:pPr algn="l">
+              <a:buNone/>
               <a:defRPr sz="1575" b="1">
                 <a:solidFill>
                   <a:srgbClr val="3D8DFF"/>
@@ -9414,6 +9494,7 @@
           <a:lstStyle xmlns:a="http://schemas.openxmlformats.org/drawingml/2006/main"/>
           <a:p xmlns:a="http://schemas.openxmlformats.org/drawingml/2006/main">
             <a:pPr algn="l">
+              <a:buNone/>
               <a:defRPr sz="1575" b="0">
                 <a:solidFill>
                   <a:srgbClr val="000000"/>
@@ -9464,6 +9545,7 @@
           <a:lstStyle xmlns:a="http://schemas.openxmlformats.org/drawingml/2006/main"/>
           <a:p xmlns:a="http://schemas.openxmlformats.org/drawingml/2006/main">
             <a:pPr algn="l">
+              <a:buNone/>
               <a:defRPr sz="1575" b="1">
                 <a:solidFill>
                   <a:srgbClr val="3D8DFF"/>
@@ -9514,6 +9596,7 @@
           <a:lstStyle xmlns:a="http://schemas.openxmlformats.org/drawingml/2006/main"/>
           <a:p xmlns:a="http://schemas.openxmlformats.org/drawingml/2006/main">
             <a:pPr algn="l">
+              <a:buNone/>
               <a:defRPr sz="1575" b="0">
                 <a:solidFill>
                   <a:srgbClr val="000000"/>
@@ -9564,6 +9647,7 @@
           <a:lstStyle xmlns:a="http://schemas.openxmlformats.org/drawingml/2006/main"/>
           <a:p xmlns:a="http://schemas.openxmlformats.org/drawingml/2006/main">
             <a:pPr algn="r">
+              <a:buNone/>
               <a:defRPr sz="975" b="0">
                 <a:solidFill>
                   <a:srgbClr val="60646C"/>
@@ -9636,6 +9720,7 @@
           <a:lstStyle xmlns:a="http://schemas.openxmlformats.org/drawingml/2006/main"/>
           <a:p xmlns:a="http://schemas.openxmlformats.org/drawingml/2006/main">
             <a:pPr algn="l">
+              <a:buNone/>
               <a:defRPr sz="1125" b="1">
                 <a:solidFill>
                   <a:srgbClr val="60646C"/>
@@ -9686,6 +9771,7 @@
           <a:lstStyle xmlns:a="http://schemas.openxmlformats.org/drawingml/2006/main"/>
           <a:p xmlns:a="http://schemas.openxmlformats.org/drawingml/2006/main">
             <a:pPr algn="l">
+              <a:buNone/>
               <a:defRPr sz="3750" b="1">
                 <a:solidFill>
                   <a:srgbClr val="000000"/>
@@ -9736,6 +9822,7 @@
           <a:lstStyle xmlns:a="http://schemas.openxmlformats.org/drawingml/2006/main"/>
           <a:p xmlns:a="http://schemas.openxmlformats.org/drawingml/2006/main">
             <a:pPr algn="l">
+              <a:buNone/>
               <a:defRPr sz="1725" b="0">
                 <a:solidFill>
                   <a:srgbClr val="60646C"/>
@@ -9819,6 +9906,7 @@
           <a:lstStyle xmlns:a="http://schemas.openxmlformats.org/drawingml/2006/main"/>
           <a:p xmlns:a="http://schemas.openxmlformats.org/drawingml/2006/main">
             <a:pPr algn="ctr">
+              <a:buNone/>
               <a:defRPr sz="2250" b="1">
                 <a:solidFill>
                   <a:srgbClr val="000000"/>
@@ -9935,6 +10023,7 @@
           <a:lstStyle xmlns:a="http://schemas.openxmlformats.org/drawingml/2006/main"/>
           <a:p xmlns:a="http://schemas.openxmlformats.org/drawingml/2006/main">
             <a:pPr algn="ctr">
+              <a:buNone/>
               <a:defRPr sz="2250" b="1">
                 <a:solidFill>
                   <a:srgbClr val="000000"/>
@@ -10051,6 +10140,7 @@
           <a:lstStyle xmlns:a="http://schemas.openxmlformats.org/drawingml/2006/main"/>
           <a:p xmlns:a="http://schemas.openxmlformats.org/drawingml/2006/main">
             <a:pPr algn="ctr">
+              <a:buNone/>
               <a:defRPr sz="2250" b="1">
                 <a:solidFill>
                   <a:srgbClr val="000000"/>
@@ -10101,6 +10191,7 @@
           <a:lstStyle xmlns:a="http://schemas.openxmlformats.org/drawingml/2006/main"/>
           <a:p xmlns:a="http://schemas.openxmlformats.org/drawingml/2006/main">
             <a:pPr algn="ctr">
+              <a:buNone/>
               <a:defRPr sz="2100" b="1">
                 <a:solidFill>
                   <a:srgbClr val="000000"/>
@@ -10151,6 +10242,7 @@
           <a:lstStyle xmlns:a="http://schemas.openxmlformats.org/drawingml/2006/main"/>
           <a:p xmlns:a="http://schemas.openxmlformats.org/drawingml/2006/main">
             <a:pPr algn="r">
+              <a:buNone/>
               <a:defRPr sz="975" b="0">
                 <a:solidFill>
                   <a:srgbClr val="60646C"/>
@@ -10223,6 +10315,7 @@
           <a:lstStyle xmlns:a="http://schemas.openxmlformats.org/drawingml/2006/main"/>
           <a:p xmlns:a="http://schemas.openxmlformats.org/drawingml/2006/main">
             <a:pPr algn="l">
+              <a:buNone/>
               <a:defRPr sz="1125" b="1">
                 <a:solidFill>
                   <a:srgbClr val="60646C"/>
@@ -10273,6 +10366,7 @@
           <a:lstStyle xmlns:a="http://schemas.openxmlformats.org/drawingml/2006/main"/>
           <a:p xmlns:a="http://schemas.openxmlformats.org/drawingml/2006/main">
             <a:pPr algn="l">
+              <a:buNone/>
               <a:defRPr sz="3750" b="1">
                 <a:solidFill>
                   <a:srgbClr val="000000"/>
@@ -10356,6 +10450,7 @@
           <a:lstStyle xmlns:a="http://schemas.openxmlformats.org/drawingml/2006/main"/>
           <a:p xmlns:a="http://schemas.openxmlformats.org/drawingml/2006/main">
             <a:pPr algn="l">
+              <a:buNone/>
               <a:defRPr sz="1650" b="1">
                 <a:solidFill>
                   <a:srgbClr val="000000"/>
@@ -10406,6 +10501,7 @@
           <a:lstStyle xmlns:a="http://schemas.openxmlformats.org/drawingml/2006/main"/>
           <a:p xmlns:a="http://schemas.openxmlformats.org/drawingml/2006/main">
             <a:pPr algn="l">
+              <a:buNone/>
               <a:defRPr sz="1200" b="0">
                 <a:solidFill>
                   <a:srgbClr val="60646C"/>
@@ -10522,6 +10618,7 @@
           <a:lstStyle xmlns:a="http://schemas.openxmlformats.org/drawingml/2006/main"/>
           <a:p xmlns:a="http://schemas.openxmlformats.org/drawingml/2006/main">
             <a:pPr algn="l">
+              <a:buNone/>
               <a:defRPr sz="1650" b="1">
                 <a:solidFill>
                   <a:srgbClr val="000000"/>
@@ -10572,6 +10669,7 @@
           <a:lstStyle xmlns:a="http://schemas.openxmlformats.org/drawingml/2006/main"/>
           <a:p xmlns:a="http://schemas.openxmlformats.org/drawingml/2006/main">
             <a:pPr algn="l">
+              <a:buNone/>
               <a:defRPr sz="1200" b="0">
                 <a:solidFill>
                   <a:srgbClr val="60646C"/>
@@ -10688,6 +10786,7 @@
           <a:lstStyle xmlns:a="http://schemas.openxmlformats.org/drawingml/2006/main"/>
           <a:p xmlns:a="http://schemas.openxmlformats.org/drawingml/2006/main">
             <a:pPr algn="l">
+              <a:buNone/>
               <a:defRPr sz="1650" b="1">
                 <a:solidFill>
                   <a:srgbClr val="000000"/>
@@ -10738,6 +10837,7 @@
           <a:lstStyle xmlns:a="http://schemas.openxmlformats.org/drawingml/2006/main"/>
           <a:p xmlns:a="http://schemas.openxmlformats.org/drawingml/2006/main">
             <a:pPr algn="l">
+              <a:buNone/>
               <a:defRPr sz="1200" b="0">
                 <a:solidFill>
                   <a:srgbClr val="60646C"/>
@@ -10854,6 +10954,7 @@
           <a:lstStyle xmlns:a="http://schemas.openxmlformats.org/drawingml/2006/main"/>
           <a:p xmlns:a="http://schemas.openxmlformats.org/drawingml/2006/main">
             <a:pPr algn="l">
+              <a:buNone/>
               <a:defRPr sz="1650" b="1">
                 <a:solidFill>
                   <a:srgbClr val="000000"/>
@@ -10871,6 +10972,7 @@
           </a:p>
           <a:p xmlns:a="http://schemas.openxmlformats.org/drawingml/2006/main">
             <a:pPr algn="l">
+              <a:buNone/>
               <a:defRPr sz="1650" b="1">
                 <a:solidFill>
                   <a:srgbClr val="000000"/>
@@ -10921,6 +11023,7 @@
           <a:lstStyle xmlns:a="http://schemas.openxmlformats.org/drawingml/2006/main"/>
           <a:p xmlns:a="http://schemas.openxmlformats.org/drawingml/2006/main">
             <a:pPr algn="l">
+              <a:buNone/>
               <a:defRPr sz="1200" b="0">
                 <a:solidFill>
                   <a:srgbClr val="60646C"/>
@@ -10938,6 +11041,7 @@
           </a:p>
           <a:p xmlns:a="http://schemas.openxmlformats.org/drawingml/2006/main">
             <a:pPr algn="l">
+              <a:buNone/>
               <a:defRPr sz="1200" b="0">
                 <a:solidFill>
                   <a:srgbClr val="60646C"/>
@@ -11054,6 +11158,7 @@
           <a:lstStyle xmlns:a="http://schemas.openxmlformats.org/drawingml/2006/main"/>
           <a:p xmlns:a="http://schemas.openxmlformats.org/drawingml/2006/main">
             <a:pPr algn="l">
+              <a:buNone/>
               <a:defRPr sz="1650" b="1">
                 <a:solidFill>
                   <a:srgbClr val="000000"/>
@@ -11071,6 +11176,7 @@
           </a:p>
           <a:p xmlns:a="http://schemas.openxmlformats.org/drawingml/2006/main">
             <a:pPr algn="l">
+              <a:buNone/>
               <a:defRPr sz="1650" b="1">
                 <a:solidFill>
                   <a:srgbClr val="000000"/>
@@ -11121,6 +11227,7 @@
           <a:lstStyle xmlns:a="http://schemas.openxmlformats.org/drawingml/2006/main"/>
           <a:p xmlns:a="http://schemas.openxmlformats.org/drawingml/2006/main">
             <a:pPr algn="l">
+              <a:buNone/>
               <a:defRPr sz="1200" b="0">
                 <a:solidFill>
                   <a:srgbClr val="60646C"/>
@@ -11138,6 +11245,7 @@
           </a:p>
           <a:p xmlns:a="http://schemas.openxmlformats.org/drawingml/2006/main">
             <a:pPr algn="l">
+              <a:buNone/>
               <a:defRPr sz="1200" b="0">
                 <a:solidFill>
                   <a:srgbClr val="60646C"/>
@@ -11188,6 +11296,7 @@
           <a:lstStyle xmlns:a="http://schemas.openxmlformats.org/drawingml/2006/main"/>
           <a:p xmlns:a="http://schemas.openxmlformats.org/drawingml/2006/main">
             <a:pPr algn="ctr">
+              <a:buNone/>
               <a:defRPr sz="2025" b="1">
                 <a:solidFill>
                   <a:srgbClr val="000000"/>
@@ -11238,6 +11347,7 @@
           <a:lstStyle xmlns:a="http://schemas.openxmlformats.org/drawingml/2006/main"/>
           <a:p xmlns:a="http://schemas.openxmlformats.org/drawingml/2006/main">
             <a:pPr algn="r">
+              <a:buNone/>
               <a:defRPr sz="975" b="0">
                 <a:solidFill>
                   <a:srgbClr val="60646C"/>
@@ -11310,6 +11420,7 @@
           <a:lstStyle xmlns:a="http://schemas.openxmlformats.org/drawingml/2006/main"/>
           <a:p xmlns:a="http://schemas.openxmlformats.org/drawingml/2006/main">
             <a:pPr algn="l">
+              <a:buNone/>
               <a:defRPr sz="1125" b="1">
                 <a:solidFill>
                   <a:srgbClr val="60646C"/>
@@ -11360,6 +11471,7 @@
           <a:lstStyle xmlns:a="http://schemas.openxmlformats.org/drawingml/2006/main"/>
           <a:p xmlns:a="http://schemas.openxmlformats.org/drawingml/2006/main">
             <a:pPr algn="l">
+              <a:buNone/>
               <a:defRPr sz="3750" b="1">
                 <a:solidFill>
                   <a:srgbClr val="000000"/>
@@ -11410,6 +11522,7 @@
           <a:lstStyle xmlns:a="http://schemas.openxmlformats.org/drawingml/2006/main"/>
           <a:p xmlns:a="http://schemas.openxmlformats.org/drawingml/2006/main">
             <a:pPr algn="l">
+              <a:buNone/>
               <a:defRPr sz="1725" b="0">
                 <a:solidFill>
                   <a:srgbClr val="60646C"/>
@@ -11493,6 +11606,7 @@
           <a:lstStyle xmlns:a="http://schemas.openxmlformats.org/drawingml/2006/main"/>
           <a:p xmlns:a="http://schemas.openxmlformats.org/drawingml/2006/main">
             <a:pPr algn="ctr">
+              <a:buNone/>
               <a:defRPr sz="2550" b="1">
                 <a:solidFill>
                   <a:srgbClr val="000000"/>
@@ -11543,6 +11657,7 @@
           <a:lstStyle xmlns:a="http://schemas.openxmlformats.org/drawingml/2006/main"/>
           <a:p xmlns:a="http://schemas.openxmlformats.org/drawingml/2006/main">
             <a:pPr algn="ctr">
+              <a:buNone/>
               <a:defRPr sz="1950" b="0">
                 <a:solidFill>
                   <a:srgbClr val="60646C"/>
@@ -11560,6 +11675,7 @@
           </a:p>
           <a:p xmlns:a="http://schemas.openxmlformats.org/drawingml/2006/main">
             <a:pPr algn="ctr">
+              <a:buNone/>
               <a:defRPr sz="1950" b="0">
                 <a:solidFill>
                   <a:srgbClr val="60646C"/>
@@ -11577,6 +11693,7 @@
           </a:p>
           <a:p xmlns:a="http://schemas.openxmlformats.org/drawingml/2006/main">
             <a:pPr algn="ctr">
+              <a:buNone/>
               <a:defRPr sz="1950" b="0">
                 <a:solidFill>
                   <a:srgbClr val="60646C"/>
@@ -11627,6 +11744,7 @@
           <a:lstStyle xmlns:a="http://schemas.openxmlformats.org/drawingml/2006/main"/>
           <a:p xmlns:a="http://schemas.openxmlformats.org/drawingml/2006/main">
             <a:pPr algn="ctr">
+              <a:buNone/>
               <a:defRPr sz="4350" b="1">
                 <a:solidFill>
                   <a:srgbClr val="3D8DFF"/>
@@ -11710,6 +11828,7 @@
           <a:lstStyle xmlns:a="http://schemas.openxmlformats.org/drawingml/2006/main"/>
           <a:p xmlns:a="http://schemas.openxmlformats.org/drawingml/2006/main">
             <a:pPr algn="ctr">
+              <a:buNone/>
               <a:defRPr sz="2550" b="1">
                 <a:solidFill>
                   <a:srgbClr val="000000"/>
@@ -11760,6 +11879,7 @@
           <a:lstStyle xmlns:a="http://schemas.openxmlformats.org/drawingml/2006/main"/>
           <a:p xmlns:a="http://schemas.openxmlformats.org/drawingml/2006/main">
             <a:pPr algn="l">
+              <a:buNone/>
               <a:defRPr sz="1650" b="1">
                 <a:solidFill>
                   <a:srgbClr val="3D8DFF"/>
@@ -11810,6 +11930,7 @@
           <a:lstStyle xmlns:a="http://schemas.openxmlformats.org/drawingml/2006/main"/>
           <a:p xmlns:a="http://schemas.openxmlformats.org/drawingml/2006/main">
             <a:pPr algn="l">
+              <a:buNone/>
               <a:defRPr sz="1650" b="0">
                 <a:solidFill>
                   <a:srgbClr val="000000"/>
@@ -11860,6 +11981,7 @@
           <a:lstStyle xmlns:a="http://schemas.openxmlformats.org/drawingml/2006/main"/>
           <a:p xmlns:a="http://schemas.openxmlformats.org/drawingml/2006/main">
             <a:pPr algn="l">
+              <a:buNone/>
               <a:defRPr sz="1650" b="1">
                 <a:solidFill>
                   <a:srgbClr val="3D8DFF"/>
@@ -11910,6 +12032,7 @@
           <a:lstStyle xmlns:a="http://schemas.openxmlformats.org/drawingml/2006/main"/>
           <a:p xmlns:a="http://schemas.openxmlformats.org/drawingml/2006/main">
             <a:pPr algn="l">
+              <a:buNone/>
               <a:defRPr sz="1650" b="0">
                 <a:solidFill>
                   <a:srgbClr val="000000"/>
@@ -11960,6 +12083,7 @@
           <a:lstStyle xmlns:a="http://schemas.openxmlformats.org/drawingml/2006/main"/>
           <a:p xmlns:a="http://schemas.openxmlformats.org/drawingml/2006/main">
             <a:pPr algn="l">
+              <a:buNone/>
               <a:defRPr sz="1650" b="1">
                 <a:solidFill>
                   <a:srgbClr val="3D8DFF"/>
@@ -12010,6 +12134,7 @@
           <a:lstStyle xmlns:a="http://schemas.openxmlformats.org/drawingml/2006/main"/>
           <a:p xmlns:a="http://schemas.openxmlformats.org/drawingml/2006/main">
             <a:pPr algn="l">
+              <a:buNone/>
               <a:defRPr sz="1650" b="0">
                 <a:solidFill>
                   <a:srgbClr val="000000"/>
@@ -12060,6 +12185,7 @@
           <a:lstStyle xmlns:a="http://schemas.openxmlformats.org/drawingml/2006/main"/>
           <a:p xmlns:a="http://schemas.openxmlformats.org/drawingml/2006/main">
             <a:pPr algn="l">
+              <a:buNone/>
               <a:defRPr sz="1650" b="1">
                 <a:solidFill>
                   <a:srgbClr val="3D8DFF"/>
@@ -12110,6 +12236,7 @@
           <a:lstStyle xmlns:a="http://schemas.openxmlformats.org/drawingml/2006/main"/>
           <a:p xmlns:a="http://schemas.openxmlformats.org/drawingml/2006/main">
             <a:pPr algn="l">
+              <a:buNone/>
               <a:defRPr sz="1650" b="0">
                 <a:solidFill>
                   <a:srgbClr val="000000"/>
@@ -12160,6 +12287,7 @@
           <a:lstStyle xmlns:a="http://schemas.openxmlformats.org/drawingml/2006/main"/>
           <a:p xmlns:a="http://schemas.openxmlformats.org/drawingml/2006/main">
             <a:pPr algn="l">
+              <a:buNone/>
               <a:defRPr sz="1650" b="1">
                 <a:solidFill>
                   <a:srgbClr val="3D8DFF"/>
@@ -12210,6 +12338,7 @@
           <a:lstStyle xmlns:a="http://schemas.openxmlformats.org/drawingml/2006/main"/>
           <a:p xmlns:a="http://schemas.openxmlformats.org/drawingml/2006/main">
             <a:pPr algn="l">
+              <a:buNone/>
               <a:defRPr sz="1650" b="0">
                 <a:solidFill>
                   <a:srgbClr val="000000"/>
@@ -12260,6 +12389,7 @@
           <a:lstStyle xmlns:a="http://schemas.openxmlformats.org/drawingml/2006/main"/>
           <a:p xmlns:a="http://schemas.openxmlformats.org/drawingml/2006/main">
             <a:pPr algn="l">
+              <a:buNone/>
               <a:defRPr sz="1650" b="1">
                 <a:solidFill>
                   <a:srgbClr val="3D8DFF"/>
@@ -12310,6 +12440,7 @@
           <a:lstStyle xmlns:a="http://schemas.openxmlformats.org/drawingml/2006/main"/>
           <a:p xmlns:a="http://schemas.openxmlformats.org/drawingml/2006/main">
             <a:pPr algn="l">
+              <a:buNone/>
               <a:defRPr sz="1650" b="0">
                 <a:solidFill>
                   <a:srgbClr val="000000"/>
@@ -12360,6 +12491,7 @@
           <a:lstStyle xmlns:a="http://schemas.openxmlformats.org/drawingml/2006/main"/>
           <a:p xmlns:a="http://schemas.openxmlformats.org/drawingml/2006/main">
             <a:pPr algn="l">
+              <a:buNone/>
               <a:defRPr sz="1650" b="1">
                 <a:solidFill>
                   <a:srgbClr val="3D8DFF"/>
@@ -12410,6 +12542,7 @@
           <a:lstStyle xmlns:a="http://schemas.openxmlformats.org/drawingml/2006/main"/>
           <a:p xmlns:a="http://schemas.openxmlformats.org/drawingml/2006/main">
             <a:pPr algn="l">
+              <a:buNone/>
               <a:defRPr sz="1650" b="0">
                 <a:solidFill>
                   <a:srgbClr val="000000"/>
@@ -12460,6 +12593,7 @@
           <a:lstStyle xmlns:a="http://schemas.openxmlformats.org/drawingml/2006/main"/>
           <a:p xmlns:a="http://schemas.openxmlformats.org/drawingml/2006/main">
             <a:pPr algn="l">
+              <a:buNone/>
               <a:defRPr sz="1650" b="1">
                 <a:solidFill>
                   <a:srgbClr val="3D8DFF"/>
@@ -12510,6 +12644,7 @@
           <a:lstStyle xmlns:a="http://schemas.openxmlformats.org/drawingml/2006/main"/>
           <a:p xmlns:a="http://schemas.openxmlformats.org/drawingml/2006/main">
             <a:pPr algn="l">
+              <a:buNone/>
               <a:defRPr sz="1650" b="0">
                 <a:solidFill>
                   <a:srgbClr val="000000"/>
@@ -12560,6 +12695,7 @@
           <a:lstStyle xmlns:a="http://schemas.openxmlformats.org/drawingml/2006/main"/>
           <a:p xmlns:a="http://schemas.openxmlformats.org/drawingml/2006/main">
             <a:pPr algn="r">
+              <a:buNone/>
               <a:defRPr sz="975" b="0">
                 <a:solidFill>
                   <a:srgbClr val="60646C"/>
@@ -12632,6 +12768,7 @@
           <a:lstStyle xmlns:a="http://schemas.openxmlformats.org/drawingml/2006/main"/>
           <a:p xmlns:a="http://schemas.openxmlformats.org/drawingml/2006/main">
             <a:pPr algn="l">
+              <a:buNone/>
               <a:defRPr sz="1125" b="1">
                 <a:solidFill>
                   <a:srgbClr val="60646C"/>
@@ -12682,14 +12819,18 @@
           <a:lstStyle xmlns:a="http://schemas.openxmlformats.org/drawingml/2006/main"/>
           <a:p xmlns:a="http://schemas.openxmlformats.org/drawingml/2006/main">
             <a:pPr algn="l">
-              <a:defRPr sz="3750" b="1">
-                <a:solidFill>
-                  <a:srgbClr val="000000"/>
-                </a:solidFill>
-              </a:defRPr>
-            </a:pPr>
-            <a:r>
-              <a:rPr sz="3750" b="1">
+              <a:lnSpc>
+                <a:spcPct val="98000"/>
+              </a:lnSpc>
+              <a:buNone/>
+              <a:defRPr sz="3375" b="1">
+                <a:solidFill>
+                  <a:srgbClr val="000000"/>
+                </a:solidFill>
+              </a:defRPr>
+            </a:pPr>
+            <a:r>
+              <a:rPr sz="3375" b="1">
                 <a:solidFill>
                   <a:srgbClr val="000000"/>
                 </a:solidFill>
@@ -12732,6 +12873,7 @@
           <a:lstStyle xmlns:a="http://schemas.openxmlformats.org/drawingml/2006/main"/>
           <a:p xmlns:a="http://schemas.openxmlformats.org/drawingml/2006/main">
             <a:pPr algn="l">
+              <a:buNone/>
               <a:defRPr sz="3225" b="1">
                 <a:solidFill>
                   <a:srgbClr val="000000"/>
@@ -12782,6 +12924,7 @@
           <a:lstStyle xmlns:a="http://schemas.openxmlformats.org/drawingml/2006/main"/>
           <a:p xmlns:a="http://schemas.openxmlformats.org/drawingml/2006/main">
             <a:pPr algn="l">
+              <a:buNone/>
               <a:defRPr sz="3225" b="1">
                 <a:solidFill>
                   <a:srgbClr val="3D8DFF"/>
@@ -12865,6 +13008,7 @@
           <a:lstStyle xmlns:a="http://schemas.openxmlformats.org/drawingml/2006/main"/>
           <a:p xmlns:a="http://schemas.openxmlformats.org/drawingml/2006/main">
             <a:pPr algn="ctr">
+              <a:buNone/>
               <a:defRPr sz="1275" b="1">
                 <a:solidFill>
                   <a:srgbClr val="000000"/>
@@ -12948,6 +13092,7 @@
           <a:lstStyle xmlns:a="http://schemas.openxmlformats.org/drawingml/2006/main"/>
           <a:p xmlns:a="http://schemas.openxmlformats.org/drawingml/2006/main">
             <a:pPr algn="ctr">
+              <a:buNone/>
               <a:defRPr sz="1275" b="1">
                 <a:solidFill>
                   <a:srgbClr val="000000"/>
@@ -13031,6 +13176,7 @@
           <a:lstStyle xmlns:a="http://schemas.openxmlformats.org/drawingml/2006/main"/>
           <a:p xmlns:a="http://schemas.openxmlformats.org/drawingml/2006/main">
             <a:pPr algn="ctr">
+              <a:buNone/>
               <a:defRPr sz="1275" b="1">
                 <a:solidFill>
                   <a:srgbClr val="000000"/>
@@ -13114,6 +13260,7 @@
           <a:lstStyle xmlns:a="http://schemas.openxmlformats.org/drawingml/2006/main"/>
           <a:p xmlns:a="http://schemas.openxmlformats.org/drawingml/2006/main">
             <a:pPr algn="ctr">
+              <a:buNone/>
               <a:defRPr sz="1275" b="1">
                 <a:solidFill>
                   <a:srgbClr val="000000"/>
@@ -13197,6 +13344,7 @@
           <a:lstStyle xmlns:a="http://schemas.openxmlformats.org/drawingml/2006/main"/>
           <a:p xmlns:a="http://schemas.openxmlformats.org/drawingml/2006/main">
             <a:pPr algn="ctr">
+              <a:buNone/>
               <a:defRPr sz="1275" b="1">
                 <a:solidFill>
                   <a:srgbClr val="000000"/>
@@ -13280,6 +13428,7 @@
           <a:lstStyle xmlns:a="http://schemas.openxmlformats.org/drawingml/2006/main"/>
           <a:p xmlns:a="http://schemas.openxmlformats.org/drawingml/2006/main">
             <a:pPr algn="ctr">
+              <a:buNone/>
               <a:defRPr sz="1275" b="1">
                 <a:solidFill>
                   <a:srgbClr val="000000"/>
@@ -13363,6 +13512,7 @@
           <a:lstStyle xmlns:a="http://schemas.openxmlformats.org/drawingml/2006/main"/>
           <a:p xmlns:a="http://schemas.openxmlformats.org/drawingml/2006/main">
             <a:pPr algn="ctr">
+              <a:buNone/>
               <a:defRPr sz="1275" b="1">
                 <a:solidFill>
                   <a:srgbClr val="000000"/>
@@ -13446,6 +13596,7 @@
           <a:lstStyle xmlns:a="http://schemas.openxmlformats.org/drawingml/2006/main"/>
           <a:p xmlns:a="http://schemas.openxmlformats.org/drawingml/2006/main">
             <a:pPr algn="ctr">
+              <a:buNone/>
               <a:defRPr sz="1275" b="1">
                 <a:solidFill>
                   <a:srgbClr val="000000"/>
@@ -13529,6 +13680,7 @@
           <a:lstStyle xmlns:a="http://schemas.openxmlformats.org/drawingml/2006/main"/>
           <a:p xmlns:a="http://schemas.openxmlformats.org/drawingml/2006/main">
             <a:pPr algn="ctr">
+              <a:buNone/>
               <a:defRPr sz="1275" b="1">
                 <a:solidFill>
                   <a:srgbClr val="000000"/>
@@ -13579,6 +13731,7 @@
           <a:lstStyle xmlns:a="http://schemas.openxmlformats.org/drawingml/2006/main"/>
           <a:p xmlns:a="http://schemas.openxmlformats.org/drawingml/2006/main">
             <a:pPr algn="r">
+              <a:buNone/>
               <a:defRPr sz="975" b="0">
                 <a:solidFill>
                   <a:srgbClr val="60646C"/>
@@ -13651,6 +13804,7 @@
           <a:lstStyle xmlns:a="http://schemas.openxmlformats.org/drawingml/2006/main"/>
           <a:p xmlns:a="http://schemas.openxmlformats.org/drawingml/2006/main">
             <a:pPr algn="l">
+              <a:buNone/>
               <a:defRPr sz="1125" b="1">
                 <a:solidFill>
                   <a:srgbClr val="60646C"/>
@@ -13701,6 +13855,7 @@
           <a:lstStyle xmlns:a="http://schemas.openxmlformats.org/drawingml/2006/main"/>
           <a:p xmlns:a="http://schemas.openxmlformats.org/drawingml/2006/main">
             <a:pPr algn="l">
+              <a:buNone/>
               <a:defRPr sz="3750" b="1">
                 <a:solidFill>
                   <a:srgbClr val="000000"/>
@@ -13784,6 +13939,7 @@
           <a:lstStyle xmlns:a="http://schemas.openxmlformats.org/drawingml/2006/main"/>
           <a:p xmlns:a="http://schemas.openxmlformats.org/drawingml/2006/main">
             <a:pPr algn="l">
+              <a:buNone/>
               <a:defRPr sz="2325" b="1">
                 <a:solidFill>
                   <a:srgbClr val="000000"/>
@@ -13834,6 +13990,7 @@
           <a:lstStyle xmlns:a="http://schemas.openxmlformats.org/drawingml/2006/main"/>
           <a:p xmlns:a="http://schemas.openxmlformats.org/drawingml/2006/main">
             <a:pPr algn="l">
+              <a:buNone/>
               <a:defRPr sz="2700" b="1">
                 <a:solidFill>
                   <a:srgbClr val="C2410C"/>
@@ -13917,6 +14074,7 @@
           <a:lstStyle xmlns:a="http://schemas.openxmlformats.org/drawingml/2006/main"/>
           <a:p xmlns:a="http://schemas.openxmlformats.org/drawingml/2006/main">
             <a:pPr algn="l">
+              <a:buNone/>
               <a:defRPr sz="2325" b="1">
                 <a:solidFill>
                   <a:srgbClr val="000000"/>
@@ -13967,6 +14125,7 @@
           <a:lstStyle xmlns:a="http://schemas.openxmlformats.org/drawingml/2006/main"/>
           <a:p xmlns:a="http://schemas.openxmlformats.org/drawingml/2006/main">
             <a:pPr algn="l">
+              <a:buNone/>
               <a:defRPr sz="2550" b="1">
                 <a:solidFill>
                   <a:srgbClr val="000000"/>
@@ -14050,6 +14209,7 @@
           <a:lstStyle xmlns:a="http://schemas.openxmlformats.org/drawingml/2006/main"/>
           <a:p xmlns:a="http://schemas.openxmlformats.org/drawingml/2006/main">
             <a:pPr algn="r">
+              <a:buNone/>
               <a:defRPr sz="975" b="0">
                 <a:solidFill>
                   <a:srgbClr val="60646C"/>
@@ -14122,6 +14282,7 @@
           <a:lstStyle xmlns:a="http://schemas.openxmlformats.org/drawingml/2006/main"/>
           <a:p xmlns:a="http://schemas.openxmlformats.org/drawingml/2006/main">
             <a:pPr algn="l">
+              <a:buNone/>
               <a:defRPr sz="1125" b="1">
                 <a:solidFill>
                   <a:srgbClr val="60646C"/>
@@ -14172,14 +14333,18 @@
           <a:lstStyle xmlns:a="http://schemas.openxmlformats.org/drawingml/2006/main"/>
           <a:p xmlns:a="http://schemas.openxmlformats.org/drawingml/2006/main">
             <a:pPr algn="l">
-              <a:defRPr sz="3750" b="1">
-                <a:solidFill>
-                  <a:srgbClr val="000000"/>
-                </a:solidFill>
-              </a:defRPr>
-            </a:pPr>
-            <a:r>
-              <a:rPr sz="3750" b="1">
+              <a:lnSpc>
+                <a:spcPct val="98000"/>
+              </a:lnSpc>
+              <a:buNone/>
+              <a:defRPr sz="3375" b="1">
+                <a:solidFill>
+                  <a:srgbClr val="000000"/>
+                </a:solidFill>
+              </a:defRPr>
+            </a:pPr>
+            <a:r>
+              <a:rPr sz="3375" b="1">
                 <a:solidFill>
                   <a:srgbClr val="000000"/>
                 </a:solidFill>
@@ -14253,6 +14418,7 @@
           <a:lstStyle xmlns:a="http://schemas.openxmlformats.org/drawingml/2006/main"/>
           <a:p xmlns:a="http://schemas.openxmlformats.org/drawingml/2006/main">
             <a:pPr algn="l">
+              <a:buNone/>
               <a:defRPr sz="1875" b="1">
                 <a:solidFill>
                   <a:srgbClr val="000000"/>
@@ -14303,6 +14469,7 @@
           <a:lstStyle xmlns:a="http://schemas.openxmlformats.org/drawingml/2006/main"/>
           <a:p xmlns:a="http://schemas.openxmlformats.org/drawingml/2006/main">
             <a:pPr algn="r">
+              <a:buNone/>
               <a:defRPr sz="1875" b="1">
                 <a:solidFill>
                   <a:srgbClr val="000000"/>
@@ -14384,6 +14551,7 @@
           <a:lstStyle xmlns:a="http://schemas.openxmlformats.org/drawingml/2006/main"/>
           <a:p xmlns:a="http://schemas.openxmlformats.org/drawingml/2006/main">
             <a:pPr algn="ctr">
+              <a:buNone/>
               <a:defRPr sz="1350" b="0">
                 <a:solidFill>
                   <a:srgbClr val="60646C"/>
@@ -14465,6 +14633,7 @@
           <a:lstStyle xmlns:a="http://schemas.openxmlformats.org/drawingml/2006/main"/>
           <a:p xmlns:a="http://schemas.openxmlformats.org/drawingml/2006/main">
             <a:pPr algn="ctr">
+              <a:buNone/>
               <a:defRPr sz="1350" b="0">
                 <a:solidFill>
                   <a:srgbClr val="60646C"/>
@@ -14546,6 +14715,7 @@
           <a:lstStyle xmlns:a="http://schemas.openxmlformats.org/drawingml/2006/main"/>
           <a:p xmlns:a="http://schemas.openxmlformats.org/drawingml/2006/main">
             <a:pPr algn="ctr">
+              <a:buNone/>
               <a:defRPr sz="1350" b="0">
                 <a:solidFill>
                   <a:srgbClr val="60646C"/>
@@ -14627,6 +14797,7 @@
           <a:lstStyle xmlns:a="http://schemas.openxmlformats.org/drawingml/2006/main"/>
           <a:p xmlns:a="http://schemas.openxmlformats.org/drawingml/2006/main">
             <a:pPr algn="ctr">
+              <a:buNone/>
               <a:defRPr sz="1350" b="0">
                 <a:solidFill>
                   <a:srgbClr val="60646C"/>
@@ -14677,6 +14848,7 @@
           <a:lstStyle xmlns:a="http://schemas.openxmlformats.org/drawingml/2006/main"/>
           <a:p xmlns:a="http://schemas.openxmlformats.org/drawingml/2006/main">
             <a:pPr algn="ctr">
+              <a:buNone/>
               <a:defRPr sz="2100" b="1">
                 <a:solidFill>
                   <a:srgbClr val="000000"/>
@@ -14727,6 +14899,7 @@
           <a:lstStyle xmlns:a="http://schemas.openxmlformats.org/drawingml/2006/main"/>
           <a:p xmlns:a="http://schemas.openxmlformats.org/drawingml/2006/main">
             <a:pPr algn="r">
+              <a:buNone/>
               <a:defRPr sz="975" b="0">
                 <a:solidFill>
                   <a:srgbClr val="60646C"/>
@@ -14799,6 +14972,7 @@
           <a:lstStyle xmlns:a="http://schemas.openxmlformats.org/drawingml/2006/main"/>
           <a:p xmlns:a="http://schemas.openxmlformats.org/drawingml/2006/main">
             <a:pPr algn="l">
+              <a:buNone/>
               <a:defRPr sz="1125" b="1">
                 <a:solidFill>
                   <a:srgbClr val="60646C"/>
@@ -14849,6 +15023,7 @@
           <a:lstStyle xmlns:a="http://schemas.openxmlformats.org/drawingml/2006/main"/>
           <a:p xmlns:a="http://schemas.openxmlformats.org/drawingml/2006/main">
             <a:pPr algn="l">
+              <a:buNone/>
               <a:defRPr sz="3750" b="1">
                 <a:solidFill>
                   <a:srgbClr val="000000"/>
@@ -14899,6 +15074,7 @@
           <a:lstStyle xmlns:a="http://schemas.openxmlformats.org/drawingml/2006/main"/>
           <a:p xmlns:a="http://schemas.openxmlformats.org/drawingml/2006/main">
             <a:pPr algn="l">
+              <a:buNone/>
               <a:defRPr sz="1725" b="0">
                 <a:solidFill>
                   <a:srgbClr val="60646C"/>
@@ -14949,6 +15125,7 @@
           <a:lstStyle xmlns:a="http://schemas.openxmlformats.org/drawingml/2006/main"/>
           <a:p xmlns:a="http://schemas.openxmlformats.org/drawingml/2006/main">
             <a:pPr algn="l">
+              <a:buNone/>
               <a:defRPr sz="2100" b="1">
                 <a:solidFill>
                   <a:srgbClr val="3D8DFF"/>
@@ -14999,6 +15176,7 @@
           <a:lstStyle xmlns:a="http://schemas.openxmlformats.org/drawingml/2006/main"/>
           <a:p xmlns:a="http://schemas.openxmlformats.org/drawingml/2006/main">
             <a:pPr algn="l">
+              <a:buNone/>
               <a:defRPr sz="2100" b="0">
                 <a:solidFill>
                   <a:srgbClr val="000000"/>
@@ -15049,6 +15227,7 @@
           <a:lstStyle xmlns:a="http://schemas.openxmlformats.org/drawingml/2006/main"/>
           <a:p xmlns:a="http://schemas.openxmlformats.org/drawingml/2006/main">
             <a:pPr algn="l">
+              <a:buNone/>
               <a:defRPr sz="2100" b="1">
                 <a:solidFill>
                   <a:srgbClr val="3D8DFF"/>
@@ -15099,6 +15278,7 @@
           <a:lstStyle xmlns:a="http://schemas.openxmlformats.org/drawingml/2006/main"/>
           <a:p xmlns:a="http://schemas.openxmlformats.org/drawingml/2006/main">
             <a:pPr algn="l">
+              <a:buNone/>
               <a:defRPr sz="2100" b="0">
                 <a:solidFill>
                   <a:srgbClr val="000000"/>
@@ -15149,6 +15329,7 @@
           <a:lstStyle xmlns:a="http://schemas.openxmlformats.org/drawingml/2006/main"/>
           <a:p xmlns:a="http://schemas.openxmlformats.org/drawingml/2006/main">
             <a:pPr algn="l">
+              <a:buNone/>
               <a:defRPr sz="2100" b="1">
                 <a:solidFill>
                   <a:srgbClr val="3D8DFF"/>
@@ -15199,6 +15380,7 @@
           <a:lstStyle xmlns:a="http://schemas.openxmlformats.org/drawingml/2006/main"/>
           <a:p xmlns:a="http://schemas.openxmlformats.org/drawingml/2006/main">
             <a:pPr algn="l">
+              <a:buNone/>
               <a:defRPr sz="2100" b="0">
                 <a:solidFill>
                   <a:srgbClr val="000000"/>
@@ -15249,6 +15431,7 @@
           <a:lstStyle xmlns:a="http://schemas.openxmlformats.org/drawingml/2006/main"/>
           <a:p xmlns:a="http://schemas.openxmlformats.org/drawingml/2006/main">
             <a:pPr algn="l">
+              <a:buNone/>
               <a:defRPr sz="2100" b="1">
                 <a:solidFill>
                   <a:srgbClr val="3D8DFF"/>
@@ -15299,6 +15482,7 @@
           <a:lstStyle xmlns:a="http://schemas.openxmlformats.org/drawingml/2006/main"/>
           <a:p xmlns:a="http://schemas.openxmlformats.org/drawingml/2006/main">
             <a:pPr algn="l">
+              <a:buNone/>
               <a:defRPr sz="2100" b="0">
                 <a:solidFill>
                   <a:srgbClr val="000000"/>
@@ -15349,6 +15533,7 @@
           <a:lstStyle xmlns:a="http://schemas.openxmlformats.org/drawingml/2006/main"/>
           <a:p xmlns:a="http://schemas.openxmlformats.org/drawingml/2006/main">
             <a:pPr algn="l">
+              <a:buNone/>
               <a:defRPr sz="2100" b="1">
                 <a:solidFill>
                   <a:srgbClr val="3D8DFF"/>
@@ -15399,6 +15584,7 @@
           <a:lstStyle xmlns:a="http://schemas.openxmlformats.org/drawingml/2006/main"/>
           <a:p xmlns:a="http://schemas.openxmlformats.org/drawingml/2006/main">
             <a:pPr algn="l">
+              <a:buNone/>
               <a:defRPr sz="2100" b="0">
                 <a:solidFill>
                   <a:srgbClr val="000000"/>
@@ -15449,6 +15635,7 @@
           <a:lstStyle xmlns:a="http://schemas.openxmlformats.org/drawingml/2006/main"/>
           <a:p xmlns:a="http://schemas.openxmlformats.org/drawingml/2006/main">
             <a:pPr algn="r">
+              <a:buNone/>
               <a:defRPr sz="975" b="0">
                 <a:solidFill>
                   <a:srgbClr val="60646C"/>

</xml_diff>